<commit_message>
Restore second PPT design (bordered centered layout v2)
Revert to commit 8176699 design: frame border, centered titles,
numbered bullets, per-lesson color themes with corner decorations.

Co-authored-by: Lin Silentium <decemberlin54-del@users.noreply.github.com>
</commit_message>
<xml_diff>
--- a/unit6-lesson21-wukong.pptx
+++ b/unit6-lesson21-wukong.pptx
@@ -13,6 +13,7 @@
     <p:sldId id="261" r:id="rId12"/>
     <p:sldId id="262" r:id="rId13"/>
     <p:sldId id="263" r:id="rId14"/>
+    <p:sldId id="264" r:id="rId15"/>
   </p:sldIdLst>
   <p:sldSz cx="12191695" cy="6858000" type="screen4x3"/>
   <p:notesSz cx="6858000" cy="9144000"/>
@@ -3304,8 +3305,8 @@
         </p:nvSpPr>
         <p:spPr>
           <a:xfrm>
-            <a:off x="1371600" y="1828800"/>
-            <a:ext cx="9418320" cy="1828800"/>
+            <a:off x="1371600" y="2011680"/>
+            <a:ext cx="9418320" cy="1645920"/>
           </a:xfrm>
           <a:prstGeom prst="rect">
             <a:avLst/>
@@ -3604,7 +3605,7 @@
                 </a:solidFill>
                 <a:latin typeface="Microsoft YaHei"/>
               </a:rPr>
-              <a:t>课堂笔记</a:t>
+              <a:t>课时目标</a:t>
             </a:r>
           </a:p>
         </p:txBody>
@@ -3617,7 +3618,7 @@
         </p:nvSpPr>
         <p:spPr>
           <a:xfrm>
-            <a:off x="1371600" y="1051560"/>
+            <a:off x="1371600" y="960120"/>
             <a:ext cx="9418320" cy="822960"/>
           </a:xfrm>
           <a:prstGeom prst="rect">
@@ -3643,7 +3644,7 @@
                 </a:solidFill>
                 <a:latin typeface="Microsoft YaHei"/>
               </a:rPr>
-              <a:t>文学常识</a:t>
+              <a:t>本课目标</a:t>
             </a:r>
           </a:p>
         </p:txBody>
@@ -3656,7 +3657,7 @@
         </p:nvSpPr>
         <p:spPr>
           <a:xfrm>
-            <a:off x="3200400" y="1691640"/>
+            <a:off x="3200400" y="1600200"/>
             <a:ext cx="5760720" cy="27432"/>
           </a:xfrm>
           <a:prstGeom prst="rect">
@@ -3699,8 +3700,8 @@
         </p:nvSpPr>
         <p:spPr>
           <a:xfrm>
-            <a:off x="1249984" y="1810512"/>
-            <a:ext cx="9692640" cy="3319272"/>
+            <a:off x="1295704" y="1645920"/>
+            <a:ext cx="9601200" cy="2240280"/>
           </a:xfrm>
           <a:prstGeom prst="roundRect">
             <a:avLst/>
@@ -3738,14 +3739,57 @@
       </p:sp>
       <p:sp>
         <p:nvSpPr>
-          <p:cNvPr id="11" name="TextBox 10"/>
+          <p:cNvPr id="11" name="Oval 10"/>
+          <p:cNvSpPr/>
+          <p:nvPr/>
+        </p:nvSpPr>
+        <p:spPr>
+          <a:xfrm>
+            <a:off x="2255824" y="1828800"/>
+            <a:ext cx="384048" cy="384048"/>
+          </a:xfrm>
+          <a:prstGeom prst="ellipse">
+            <a:avLst/>
+          </a:prstGeom>
+          <a:solidFill>
+            <a:srgbClr val="DC5028"/>
+          </a:solidFill>
+          <a:ln>
+            <a:noFill/>
+          </a:ln>
+        </p:spPr>
+        <p:style>
+          <a:lnRef idx="1">
+            <a:schemeClr val="accent1"/>
+          </a:lnRef>
+          <a:fillRef idx="3">
+            <a:schemeClr val="accent1"/>
+          </a:fillRef>
+          <a:effectRef idx="2">
+            <a:schemeClr val="accent1"/>
+          </a:effectRef>
+          <a:fontRef idx="minor">
+            <a:schemeClr val="lt1"/>
+          </a:fontRef>
+        </p:style>
+        <p:txBody>
+          <a:bodyPr rtlCol="0" anchor="ctr"/>
+          <a:lstStyle/>
+          <a:p>
+            <a:pPr algn="ctr"/>
+          </a:p>
+        </p:txBody>
+      </p:sp>
+      <p:sp>
+        <p:nvSpPr>
+          <p:cNvPr id="12" name="TextBox 11"/>
           <p:cNvSpPr txBox="1"/>
           <p:nvPr/>
         </p:nvSpPr>
         <p:spPr>
           <a:xfrm>
-            <a:off x="1463040" y="1920240"/>
-            <a:ext cx="2103120" cy="502920"/>
+            <a:off x="2255824" y="1847088"/>
+            <a:ext cx="384048" cy="365760"/>
           </a:xfrm>
           <a:prstGeom prst="rect">
             <a:avLst/>
@@ -3758,33 +3802,33 @@
           </a:bodyPr>
           <a:lstStyle/>
           <a:p>
-            <a:pPr algn="r">
+            <a:pPr algn="ctr">
               <a:spcAft>
                 <a:spcPts val="1000"/>
               </a:spcAft>
             </a:pPr>
             <a:r>
-              <a:rPr sz="2200" b="1">
+              <a:rPr sz="1600" b="1">
                 <a:solidFill>
-                  <a:srgbClr val="DC5028"/>
+                  <a:srgbClr val="FFFFFF"/>
                 </a:solidFill>
                 <a:latin typeface="Microsoft YaHei"/>
               </a:rPr>
-              <a:t>作者</a:t>
-            </a:r>
-          </a:p>
-        </p:txBody>
-      </p:sp>
-      <p:sp>
-        <p:nvSpPr>
-          <p:cNvPr id="12" name="TextBox 11"/>
+              <a:t>1</a:t>
+            </a:r>
+          </a:p>
+        </p:txBody>
+      </p:sp>
+      <p:sp>
+        <p:nvSpPr>
+          <p:cNvPr id="13" name="TextBox 12"/>
           <p:cNvSpPr txBox="1"/>
           <p:nvPr/>
         </p:nvSpPr>
         <p:spPr>
           <a:xfrm>
-            <a:off x="3749039" y="1920240"/>
-            <a:ext cx="7132320" cy="685800"/>
+            <a:off x="2758744" y="1810512"/>
+            <a:ext cx="7772400" cy="502920"/>
           </a:xfrm>
           <a:prstGeom prst="rect">
             <a:avLst/>
@@ -3803,27 +3847,70 @@
               </a:spcAft>
             </a:pPr>
             <a:r>
-              <a:rPr sz="2200" b="0">
+              <a:rPr sz="2400" b="0">
                 <a:solidFill>
                   <a:srgbClr val="502814"/>
                 </a:solidFill>
                 <a:latin typeface="Microsoft YaHei"/>
               </a:rPr>
-              <a:t>吴承恩，明代小说家</a:t>
-            </a:r>
-          </a:p>
-        </p:txBody>
-      </p:sp>
-      <p:sp>
-        <p:nvSpPr>
-          <p:cNvPr id="13" name="TextBox 12"/>
+              <a:t>梳理孙悟空与二郎神的变化链，概括故事经过</a:t>
+            </a:r>
+          </a:p>
+        </p:txBody>
+      </p:sp>
+      <p:sp>
+        <p:nvSpPr>
+          <p:cNvPr id="14" name="Oval 13"/>
+          <p:cNvSpPr/>
+          <p:nvPr/>
+        </p:nvSpPr>
+        <p:spPr>
+          <a:xfrm>
+            <a:off x="2255824" y="2395728"/>
+            <a:ext cx="384048" cy="384048"/>
+          </a:xfrm>
+          <a:prstGeom prst="ellipse">
+            <a:avLst/>
+          </a:prstGeom>
+          <a:solidFill>
+            <a:srgbClr val="DC5028"/>
+          </a:solidFill>
+          <a:ln>
+            <a:noFill/>
+          </a:ln>
+        </p:spPr>
+        <p:style>
+          <a:lnRef idx="1">
+            <a:schemeClr val="accent1"/>
+          </a:lnRef>
+          <a:fillRef idx="3">
+            <a:schemeClr val="accent1"/>
+          </a:fillRef>
+          <a:effectRef idx="2">
+            <a:schemeClr val="accent1"/>
+          </a:effectRef>
+          <a:fontRef idx="minor">
+            <a:schemeClr val="lt1"/>
+          </a:fontRef>
+        </p:style>
+        <p:txBody>
+          <a:bodyPr rtlCol="0" anchor="ctr"/>
+          <a:lstStyle/>
+          <a:p>
+            <a:pPr algn="ctr"/>
+          </a:p>
+        </p:txBody>
+      </p:sp>
+      <p:sp>
+        <p:nvSpPr>
+          <p:cNvPr id="15" name="TextBox 14"/>
           <p:cNvSpPr txBox="1"/>
           <p:nvPr/>
         </p:nvSpPr>
         <p:spPr>
           <a:xfrm>
-            <a:off x="1463040" y="2670048"/>
-            <a:ext cx="2103120" cy="502920"/>
+            <a:off x="2255824" y="2414016"/>
+            <a:ext cx="384048" cy="365760"/>
           </a:xfrm>
           <a:prstGeom prst="rect">
             <a:avLst/>
@@ -3836,33 +3923,33 @@
           </a:bodyPr>
           <a:lstStyle/>
           <a:p>
-            <a:pPr algn="r">
+            <a:pPr algn="ctr">
               <a:spcAft>
                 <a:spcPts val="1000"/>
               </a:spcAft>
             </a:pPr>
             <a:r>
-              <a:rPr sz="2200" b="1">
+              <a:rPr sz="1600" b="1">
                 <a:solidFill>
-                  <a:srgbClr val="DC5028"/>
+                  <a:srgbClr val="FFFFFF"/>
                 </a:solidFill>
                 <a:latin typeface="Microsoft YaHei"/>
               </a:rPr>
-              <a:t>出处</a:t>
-            </a:r>
-          </a:p>
-        </p:txBody>
-      </p:sp>
-      <p:sp>
-        <p:nvSpPr>
-          <p:cNvPr id="14" name="TextBox 13"/>
+              <a:t>2</a:t>
+            </a:r>
+          </a:p>
+        </p:txBody>
+      </p:sp>
+      <p:sp>
+        <p:nvSpPr>
+          <p:cNvPr id="16" name="TextBox 15"/>
           <p:cNvSpPr txBox="1"/>
           <p:nvPr/>
         </p:nvSpPr>
         <p:spPr>
           <a:xfrm>
-            <a:off x="3749039" y="2670048"/>
-            <a:ext cx="7132320" cy="685800"/>
+            <a:off x="2758744" y="2377440"/>
+            <a:ext cx="7772400" cy="502920"/>
           </a:xfrm>
           <a:prstGeom prst="rect">
             <a:avLst/>
@@ -3881,27 +3968,70 @@
               </a:spcAft>
             </a:pPr>
             <a:r>
-              <a:rPr sz="2200" b="0">
+              <a:rPr sz="2400" b="0">
                 <a:solidFill>
                   <a:srgbClr val="502814"/>
                 </a:solidFill>
                 <a:latin typeface="Microsoft YaHei"/>
               </a:rPr>
-              <a:t>章回体长篇小说《西游记》节选</a:t>
-            </a:r>
-          </a:p>
-        </p:txBody>
-      </p:sp>
-      <p:sp>
-        <p:nvSpPr>
-          <p:cNvPr id="15" name="TextBox 14"/>
+              <a:t>分析神魔形象及小说想象的趣味</a:t>
+            </a:r>
+          </a:p>
+        </p:txBody>
+      </p:sp>
+      <p:sp>
+        <p:nvSpPr>
+          <p:cNvPr id="17" name="Oval 16"/>
+          <p:cNvSpPr/>
+          <p:nvPr/>
+        </p:nvSpPr>
+        <p:spPr>
+          <a:xfrm>
+            <a:off x="2255824" y="2962656"/>
+            <a:ext cx="384048" cy="384048"/>
+          </a:xfrm>
+          <a:prstGeom prst="ellipse">
+            <a:avLst/>
+          </a:prstGeom>
+          <a:solidFill>
+            <a:srgbClr val="DC5028"/>
+          </a:solidFill>
+          <a:ln>
+            <a:noFill/>
+          </a:ln>
+        </p:spPr>
+        <p:style>
+          <a:lnRef idx="1">
+            <a:schemeClr val="accent1"/>
+          </a:lnRef>
+          <a:fillRef idx="3">
+            <a:schemeClr val="accent1"/>
+          </a:fillRef>
+          <a:effectRef idx="2">
+            <a:schemeClr val="accent1"/>
+          </a:effectRef>
+          <a:fontRef idx="minor">
+            <a:schemeClr val="lt1"/>
+          </a:fontRef>
+        </p:style>
+        <p:txBody>
+          <a:bodyPr rtlCol="0" anchor="ctr"/>
+          <a:lstStyle/>
+          <a:p>
+            <a:pPr algn="ctr"/>
+          </a:p>
+        </p:txBody>
+      </p:sp>
+      <p:sp>
+        <p:nvSpPr>
+          <p:cNvPr id="18" name="TextBox 17"/>
           <p:cNvSpPr txBox="1"/>
           <p:nvPr/>
         </p:nvSpPr>
         <p:spPr>
           <a:xfrm>
-            <a:off x="1463040" y="3419856"/>
-            <a:ext cx="2103120" cy="502920"/>
+            <a:off x="2255824" y="2980944"/>
+            <a:ext cx="384048" cy="365760"/>
           </a:xfrm>
           <a:prstGeom prst="rect">
             <a:avLst/>
@@ -3914,33 +4044,33 @@
           </a:bodyPr>
           <a:lstStyle/>
           <a:p>
-            <a:pPr algn="r">
+            <a:pPr algn="ctr">
               <a:spcAft>
                 <a:spcPts val="1000"/>
               </a:spcAft>
             </a:pPr>
             <a:r>
-              <a:rPr sz="2200" b="1">
+              <a:rPr sz="1600" b="1">
                 <a:solidFill>
-                  <a:srgbClr val="DC5028"/>
+                  <a:srgbClr val="FFFFFF"/>
                 </a:solidFill>
                 <a:latin typeface="Microsoft YaHei"/>
               </a:rPr>
-              <a:t>文体</a:t>
-            </a:r>
-          </a:p>
-        </p:txBody>
-      </p:sp>
-      <p:sp>
-        <p:nvSpPr>
-          <p:cNvPr id="16" name="TextBox 15"/>
+              <a:t>3</a:t>
+            </a:r>
+          </a:p>
+        </p:txBody>
+      </p:sp>
+      <p:sp>
+        <p:nvSpPr>
+          <p:cNvPr id="19" name="TextBox 18"/>
           <p:cNvSpPr txBox="1"/>
           <p:nvPr/>
         </p:nvSpPr>
         <p:spPr>
           <a:xfrm>
-            <a:off x="3749039" y="3419856"/>
-            <a:ext cx="7132320" cy="685800"/>
+            <a:off x="2758744" y="2944368"/>
+            <a:ext cx="7772400" cy="502920"/>
           </a:xfrm>
           <a:prstGeom prst="rect">
             <a:avLst/>
@@ -3959,91 +4089,13 @@
               </a:spcAft>
             </a:pPr>
             <a:r>
-              <a:rPr sz="2200" b="0">
+              <a:rPr sz="2400" b="0">
                 <a:solidFill>
                   <a:srgbClr val="502814"/>
                 </a:solidFill>
                 <a:latin typeface="Microsoft YaHei"/>
               </a:rPr>
-              <a:t>神魔小说——以神魔斗法写人情世故</a:t>
-            </a:r>
-          </a:p>
-        </p:txBody>
-      </p:sp>
-      <p:sp>
-        <p:nvSpPr>
-          <p:cNvPr id="17" name="TextBox 16"/>
-          <p:cNvSpPr txBox="1"/>
-          <p:nvPr/>
-        </p:nvSpPr>
-        <p:spPr>
-          <a:xfrm>
-            <a:off x="1463040" y="4169664"/>
-            <a:ext cx="2103120" cy="502920"/>
-          </a:xfrm>
-          <a:prstGeom prst="rect">
-            <a:avLst/>
-          </a:prstGeom>
-          <a:noFill/>
-        </p:spPr>
-        <p:txBody>
-          <a:bodyPr wrap="none">
-            <a:spAutoFit/>
-          </a:bodyPr>
-          <a:lstStyle/>
-          <a:p>
-            <a:pPr algn="r">
-              <a:spcAft>
-                <a:spcPts val="1000"/>
-              </a:spcAft>
-            </a:pPr>
-            <a:r>
-              <a:rPr sz="2200" b="1">
-                <a:solidFill>
-                  <a:srgbClr val="DC5028"/>
-                </a:solidFill>
-                <a:latin typeface="Microsoft YaHei"/>
-              </a:rPr>
-              <a:t>本文情节</a:t>
-            </a:r>
-          </a:p>
-        </p:txBody>
-      </p:sp>
-      <p:sp>
-        <p:nvSpPr>
-          <p:cNvPr id="18" name="TextBox 17"/>
-          <p:cNvSpPr txBox="1"/>
-          <p:nvPr/>
-        </p:nvSpPr>
-        <p:spPr>
-          <a:xfrm>
-            <a:off x="3749039" y="4169664"/>
-            <a:ext cx="7132320" cy="685800"/>
-          </a:xfrm>
-          <a:prstGeom prst="rect">
-            <a:avLst/>
-          </a:prstGeom>
-          <a:noFill/>
-        </p:spPr>
-        <p:txBody>
-          <a:bodyPr wrap="none">
-            <a:spAutoFit/>
-          </a:bodyPr>
-          <a:lstStyle/>
-          <a:p>
-            <a:pPr algn="l">
-              <a:spcAft>
-                <a:spcPts val="1000"/>
-              </a:spcAft>
-            </a:pPr>
-            <a:r>
-              <a:rPr sz="2200" b="0">
-                <a:solidFill>
-                  <a:srgbClr val="502814"/>
-                </a:solidFill>
-                <a:latin typeface="Microsoft YaHei"/>
-              </a:rPr>
-              <a:t>孙悟空大闹天宫后，二郎神奉旨捉拿，二人变化斗法</a:t>
+              <a:t>探究「自由与规则」母题，提炼策展主题一</a:t>
             </a:r>
           </a:p>
         </p:txBody>
@@ -4189,7 +4241,7 @@
         </p:nvSpPr>
         <p:spPr>
           <a:xfrm>
-            <a:off x="4953304" y="502920"/>
+            <a:off x="4953304" y="1005840"/>
             <a:ext cx="2286000" cy="411480"/>
           </a:xfrm>
           <a:prstGeom prst="roundRect">
@@ -4232,7 +4284,7 @@
         </p:nvSpPr>
         <p:spPr>
           <a:xfrm>
-            <a:off x="4953304" y="521208"/>
+            <a:off x="4953304" y="1024128"/>
             <a:ext cx="2286000" cy="384048"/>
           </a:xfrm>
           <a:prstGeom prst="rect">
@@ -4258,7 +4310,7 @@
                 </a:solidFill>
                 <a:latin typeface="Microsoft YaHei"/>
               </a:rPr>
-              <a:t>情节笔记</a:t>
+              <a:t>想一想</a:t>
             </a:r>
           </a:p>
         </p:txBody>
@@ -4271,7 +4323,7 @@
         </p:nvSpPr>
         <p:spPr>
           <a:xfrm>
-            <a:off x="1371600" y="1051560"/>
+            <a:off x="1371600" y="1600200"/>
             <a:ext cx="9418320" cy="822960"/>
           </a:xfrm>
           <a:prstGeom prst="rect">
@@ -4291,13 +4343,13 @@
               </a:spcAft>
             </a:pPr>
             <a:r>
-              <a:rPr sz="3600" b="1">
+              <a:rPr sz="3200" b="1">
                 <a:solidFill>
                   <a:srgbClr val="DC5028"/>
                 </a:solidFill>
                 <a:latin typeface="Microsoft YaHei"/>
               </a:rPr>
-              <a:t>变化链梳理</a:t>
+              <a:t>高手过招，吸引人的不只是「谁赢了」</a:t>
             </a:r>
           </a:p>
         </p:txBody>
@@ -4310,7 +4362,7 @@
         </p:nvSpPr>
         <p:spPr>
           <a:xfrm>
-            <a:off x="3200400" y="1691640"/>
+            <a:off x="3200400" y="4389120"/>
             <a:ext cx="5760720" cy="27432"/>
           </a:xfrm>
           <a:prstGeom prst="rect">
@@ -4347,59 +4399,14 @@
       </p:sp>
       <p:sp>
         <p:nvSpPr>
-          <p:cNvPr id="10" name="Rounded Rectangle 9"/>
-          <p:cNvSpPr/>
-          <p:nvPr/>
-        </p:nvSpPr>
-        <p:spPr>
-          <a:xfrm>
-            <a:off x="1249984" y="1810512"/>
-            <a:ext cx="9692640" cy="3319272"/>
-          </a:xfrm>
-          <a:prstGeom prst="roundRect">
-            <a:avLst/>
-          </a:prstGeom>
-          <a:solidFill>
-            <a:srgbClr val="FFF8F0"/>
-          </a:solidFill>
-          <a:ln w="19050">
-            <a:solidFill>
-              <a:srgbClr val="FFB464"/>
-            </a:solidFill>
-          </a:ln>
-        </p:spPr>
-        <p:style>
-          <a:lnRef idx="1">
-            <a:schemeClr val="accent1"/>
-          </a:lnRef>
-          <a:fillRef idx="3">
-            <a:schemeClr val="accent1"/>
-          </a:fillRef>
-          <a:effectRef idx="2">
-            <a:schemeClr val="accent1"/>
-          </a:effectRef>
-          <a:fontRef idx="minor">
-            <a:schemeClr val="lt1"/>
-          </a:fontRef>
-        </p:style>
-        <p:txBody>
-          <a:bodyPr rtlCol="0" anchor="ctr"/>
-          <a:lstStyle/>
-          <a:p>
-            <a:pPr algn="ctr"/>
-          </a:p>
-        </p:txBody>
-      </p:sp>
-      <p:sp>
-        <p:nvSpPr>
-          <p:cNvPr id="11" name="TextBox 10"/>
+          <p:cNvPr id="10" name="TextBox 9"/>
           <p:cNvSpPr txBox="1"/>
           <p:nvPr/>
         </p:nvSpPr>
         <p:spPr>
           <a:xfrm>
-            <a:off x="1463040" y="1920240"/>
-            <a:ext cx="2103120" cy="502920"/>
+            <a:off x="1828800" y="4663440"/>
+            <a:ext cx="8503920" cy="914400"/>
           </a:xfrm>
           <a:prstGeom prst="rect">
             <a:avLst/>
@@ -4412,292 +4419,19 @@
           </a:bodyPr>
           <a:lstStyle/>
           <a:p>
-            <a:pPr algn="r">
+            <a:pPr algn="ctr">
               <a:spcAft>
                 <a:spcPts val="1000"/>
               </a:spcAft>
             </a:pPr>
             <a:r>
-              <a:rPr sz="2200" b="1">
+              <a:rPr sz="2200" b="0">
                 <a:solidFill>
                   <a:srgbClr val="DC5028"/>
                 </a:solidFill>
                 <a:latin typeface="Microsoft YaHei"/>
               </a:rPr>
-              <a:t>第1轮</a:t>
-            </a:r>
-          </a:p>
-        </p:txBody>
-      </p:sp>
-      <p:sp>
-        <p:nvSpPr>
-          <p:cNvPr id="12" name="TextBox 11"/>
-          <p:cNvSpPr txBox="1"/>
-          <p:nvPr/>
-        </p:nvSpPr>
-        <p:spPr>
-          <a:xfrm>
-            <a:off x="3749039" y="1920240"/>
-            <a:ext cx="7132320" cy="685800"/>
-          </a:xfrm>
-          <a:prstGeom prst="rect">
-            <a:avLst/>
-          </a:prstGeom>
-          <a:noFill/>
-        </p:spPr>
-        <p:txBody>
-          <a:bodyPr wrap="none">
-            <a:spAutoFit/>
-          </a:bodyPr>
-          <a:lstStyle/>
-          <a:p>
-            <a:pPr algn="l">
-              <a:spcAft>
-                <a:spcPts val="1000"/>
-              </a:spcAft>
-            </a:pPr>
-            <a:r>
-              <a:rPr sz="2200" b="0">
-                <a:solidFill>
-                  <a:srgbClr val="502814"/>
-                </a:solidFill>
-                <a:latin typeface="Microsoft YaHei"/>
-              </a:rPr>
-              <a:t>悟空变鸟→二郎变鹰；悟空变鱼→二郎变鱼鹰</a:t>
-            </a:r>
-          </a:p>
-        </p:txBody>
-      </p:sp>
-      <p:sp>
-        <p:nvSpPr>
-          <p:cNvPr id="13" name="TextBox 12"/>
-          <p:cNvSpPr txBox="1"/>
-          <p:nvPr/>
-        </p:nvSpPr>
-        <p:spPr>
-          <a:xfrm>
-            <a:off x="1463040" y="2670048"/>
-            <a:ext cx="2103120" cy="502920"/>
-          </a:xfrm>
-          <a:prstGeom prst="rect">
-            <a:avLst/>
-          </a:prstGeom>
-          <a:noFill/>
-        </p:spPr>
-        <p:txBody>
-          <a:bodyPr wrap="none">
-            <a:spAutoFit/>
-          </a:bodyPr>
-          <a:lstStyle/>
-          <a:p>
-            <a:pPr algn="r">
-              <a:spcAft>
-                <a:spcPts val="1000"/>
-              </a:spcAft>
-            </a:pPr>
-            <a:r>
-              <a:rPr sz="2200" b="1">
-                <a:solidFill>
-                  <a:srgbClr val="DC5028"/>
-                </a:solidFill>
-                <a:latin typeface="Microsoft YaHei"/>
-              </a:rPr>
-              <a:t>第2轮</a:t>
-            </a:r>
-          </a:p>
-        </p:txBody>
-      </p:sp>
-      <p:sp>
-        <p:nvSpPr>
-          <p:cNvPr id="14" name="TextBox 13"/>
-          <p:cNvSpPr txBox="1"/>
-          <p:nvPr/>
-        </p:nvSpPr>
-        <p:spPr>
-          <a:xfrm>
-            <a:off x="3749039" y="2670048"/>
-            <a:ext cx="7132320" cy="685800"/>
-          </a:xfrm>
-          <a:prstGeom prst="rect">
-            <a:avLst/>
-          </a:prstGeom>
-          <a:noFill/>
-        </p:spPr>
-        <p:txBody>
-          <a:bodyPr wrap="none">
-            <a:spAutoFit/>
-          </a:bodyPr>
-          <a:lstStyle/>
-          <a:p>
-            <a:pPr algn="l">
-              <a:spcAft>
-                <a:spcPts val="1000"/>
-              </a:spcAft>
-            </a:pPr>
-            <a:r>
-              <a:rPr sz="2200" b="0">
-                <a:solidFill>
-                  <a:srgbClr val="502814"/>
-                </a:solidFill>
-                <a:latin typeface="Microsoft YaHei"/>
-              </a:rPr>
-              <a:t>悟空变水蛇→二郎变灰鹤；悟空变花鸨→二郎现原身</a:t>
-            </a:r>
-          </a:p>
-        </p:txBody>
-      </p:sp>
-      <p:sp>
-        <p:nvSpPr>
-          <p:cNvPr id="15" name="TextBox 14"/>
-          <p:cNvSpPr txBox="1"/>
-          <p:nvPr/>
-        </p:nvSpPr>
-        <p:spPr>
-          <a:xfrm>
-            <a:off x="1463040" y="3419856"/>
-            <a:ext cx="2103120" cy="502920"/>
-          </a:xfrm>
-          <a:prstGeom prst="rect">
-            <a:avLst/>
-          </a:prstGeom>
-          <a:noFill/>
-        </p:spPr>
-        <p:txBody>
-          <a:bodyPr wrap="none">
-            <a:spAutoFit/>
-          </a:bodyPr>
-          <a:lstStyle/>
-          <a:p>
-            <a:pPr algn="r">
-              <a:spcAft>
-                <a:spcPts val="1000"/>
-              </a:spcAft>
-            </a:pPr>
-            <a:r>
-              <a:rPr sz="2200" b="1">
-                <a:solidFill>
-                  <a:srgbClr val="DC5028"/>
-                </a:solidFill>
-                <a:latin typeface="Microsoft YaHei"/>
-              </a:rPr>
-              <a:t>第3轮</a:t>
-            </a:r>
-          </a:p>
-        </p:txBody>
-      </p:sp>
-      <p:sp>
-        <p:nvSpPr>
-          <p:cNvPr id="16" name="TextBox 15"/>
-          <p:cNvSpPr txBox="1"/>
-          <p:nvPr/>
-        </p:nvSpPr>
-        <p:spPr>
-          <a:xfrm>
-            <a:off x="3749039" y="3419856"/>
-            <a:ext cx="7132320" cy="685800"/>
-          </a:xfrm>
-          <a:prstGeom prst="rect">
-            <a:avLst/>
-          </a:prstGeom>
-          <a:noFill/>
-        </p:spPr>
-        <p:txBody>
-          <a:bodyPr wrap="none">
-            <a:spAutoFit/>
-          </a:bodyPr>
-          <a:lstStyle/>
-          <a:p>
-            <a:pPr algn="l">
-              <a:spcAft>
-                <a:spcPts val="1000"/>
-              </a:spcAft>
-            </a:pPr>
-            <a:r>
-              <a:rPr sz="2200" b="0">
-                <a:solidFill>
-                  <a:srgbClr val="502814"/>
-                </a:solidFill>
-                <a:latin typeface="Microsoft YaHei"/>
-              </a:rPr>
-              <a:t>悟空变庙宇，尾巴变旗竿→二郎识破</a:t>
-            </a:r>
-          </a:p>
-        </p:txBody>
-      </p:sp>
-      <p:sp>
-        <p:nvSpPr>
-          <p:cNvPr id="17" name="TextBox 16"/>
-          <p:cNvSpPr txBox="1"/>
-          <p:nvPr/>
-        </p:nvSpPr>
-        <p:spPr>
-          <a:xfrm>
-            <a:off x="1463040" y="4169664"/>
-            <a:ext cx="2103120" cy="502920"/>
-          </a:xfrm>
-          <a:prstGeom prst="rect">
-            <a:avLst/>
-          </a:prstGeom>
-          <a:noFill/>
-        </p:spPr>
-        <p:txBody>
-          <a:bodyPr wrap="none">
-            <a:spAutoFit/>
-          </a:bodyPr>
-          <a:lstStyle/>
-          <a:p>
-            <a:pPr algn="r">
-              <a:spcAft>
-                <a:spcPts val="1000"/>
-              </a:spcAft>
-            </a:pPr>
-            <a:r>
-              <a:rPr sz="2200" b="1">
-                <a:solidFill>
-                  <a:srgbClr val="DC5028"/>
-                </a:solidFill>
-                <a:latin typeface="Microsoft YaHei"/>
-              </a:rPr>
-              <a:t>规律</a:t>
-            </a:r>
-          </a:p>
-        </p:txBody>
-      </p:sp>
-      <p:sp>
-        <p:nvSpPr>
-          <p:cNvPr id="18" name="TextBox 17"/>
-          <p:cNvSpPr txBox="1"/>
-          <p:nvPr/>
-        </p:nvSpPr>
-        <p:spPr>
-          <a:xfrm>
-            <a:off x="3749039" y="4169664"/>
-            <a:ext cx="7132320" cy="685800"/>
-          </a:xfrm>
-          <a:prstGeom prst="rect">
-            <a:avLst/>
-          </a:prstGeom>
-          <a:noFill/>
-        </p:spPr>
-        <p:txBody>
-          <a:bodyPr wrap="none">
-            <a:spAutoFit/>
-          </a:bodyPr>
-          <a:lstStyle/>
-          <a:p>
-            <a:pPr algn="l">
-              <a:spcAft>
-                <a:spcPts val="1000"/>
-              </a:spcAft>
-            </a:pPr>
-            <a:r>
-              <a:rPr sz="2200" b="0">
-                <a:solidFill>
-                  <a:srgbClr val="502814"/>
-                </a:solidFill>
-                <a:latin typeface="Microsoft YaHei"/>
-              </a:rPr>
-              <a:t>孙悟空先变，二郎神随即以相克之物相对</a:t>
+              <a:t>把自己当作赛事解说员，抓住每一次变化</a:t>
             </a:r>
           </a:p>
         </p:txBody>
@@ -4912,7 +4646,7 @@
                 </a:solidFill>
                 <a:latin typeface="Microsoft YaHei"/>
               </a:rPr>
-              <a:t>人物笔记</a:t>
+              <a:t>变形追逐图</a:t>
             </a:r>
           </a:p>
         </p:txBody>
@@ -4925,7 +4659,7 @@
         </p:nvSpPr>
         <p:spPr>
           <a:xfrm>
-            <a:off x="1371600" y="1051560"/>
+            <a:off x="1371600" y="960120"/>
             <a:ext cx="9418320" cy="822960"/>
           </a:xfrm>
           <a:prstGeom prst="rect">
@@ -4951,7 +4685,7 @@
                 </a:solidFill>
                 <a:latin typeface="Microsoft YaHei"/>
               </a:rPr>
-              <a:t>人物赏析</a:t>
+              <a:t>学习任务一</a:t>
             </a:r>
           </a:p>
         </p:txBody>
@@ -4964,7 +4698,7 @@
         </p:nvSpPr>
         <p:spPr>
           <a:xfrm>
-            <a:off x="3200400" y="1691640"/>
+            <a:off x="3200400" y="1600200"/>
             <a:ext cx="5760720" cy="27432"/>
           </a:xfrm>
           <a:prstGeom prst="rect">
@@ -5007,8 +4741,8 @@
         </p:nvSpPr>
         <p:spPr>
           <a:xfrm>
-            <a:off x="1249984" y="1810512"/>
-            <a:ext cx="9692640" cy="3319272"/>
+            <a:off x="1295704" y="1645920"/>
+            <a:ext cx="9601200" cy="2240280"/>
           </a:xfrm>
           <a:prstGeom prst="roundRect">
             <a:avLst/>
@@ -5046,14 +4780,57 @@
       </p:sp>
       <p:sp>
         <p:nvSpPr>
-          <p:cNvPr id="11" name="TextBox 10"/>
+          <p:cNvPr id="11" name="Oval 10"/>
+          <p:cNvSpPr/>
+          <p:nvPr/>
+        </p:nvSpPr>
+        <p:spPr>
+          <a:xfrm>
+            <a:off x="2255824" y="1828800"/>
+            <a:ext cx="384048" cy="384048"/>
+          </a:xfrm>
+          <a:prstGeom prst="ellipse">
+            <a:avLst/>
+          </a:prstGeom>
+          <a:solidFill>
+            <a:srgbClr val="DC5028"/>
+          </a:solidFill>
+          <a:ln>
+            <a:noFill/>
+          </a:ln>
+        </p:spPr>
+        <p:style>
+          <a:lnRef idx="1">
+            <a:schemeClr val="accent1"/>
+          </a:lnRef>
+          <a:fillRef idx="3">
+            <a:schemeClr val="accent1"/>
+          </a:fillRef>
+          <a:effectRef idx="2">
+            <a:schemeClr val="accent1"/>
+          </a:effectRef>
+          <a:fontRef idx="minor">
+            <a:schemeClr val="lt1"/>
+          </a:fontRef>
+        </p:style>
+        <p:txBody>
+          <a:bodyPr rtlCol="0" anchor="ctr"/>
+          <a:lstStyle/>
+          <a:p>
+            <a:pPr algn="ctr"/>
+          </a:p>
+        </p:txBody>
+      </p:sp>
+      <p:sp>
+        <p:nvSpPr>
+          <p:cNvPr id="12" name="TextBox 11"/>
           <p:cNvSpPr txBox="1"/>
           <p:nvPr/>
         </p:nvSpPr>
         <p:spPr>
           <a:xfrm>
-            <a:off x="1463040" y="1920240"/>
-            <a:ext cx="2103120" cy="502920"/>
+            <a:off x="2255824" y="1847088"/>
+            <a:ext cx="384048" cy="365760"/>
           </a:xfrm>
           <a:prstGeom prst="rect">
             <a:avLst/>
@@ -5066,33 +4843,33 @@
           </a:bodyPr>
           <a:lstStyle/>
           <a:p>
-            <a:pPr algn="r">
+            <a:pPr algn="ctr">
               <a:spcAft>
                 <a:spcPts val="1000"/>
               </a:spcAft>
             </a:pPr>
             <a:r>
-              <a:rPr sz="2200" b="1">
+              <a:rPr sz="1600" b="1">
                 <a:solidFill>
-                  <a:srgbClr val="DC5028"/>
+                  <a:srgbClr val="FFFFFF"/>
                 </a:solidFill>
                 <a:latin typeface="Microsoft YaHei"/>
               </a:rPr>
-              <a:t>孙悟空</a:t>
-            </a:r>
-          </a:p>
-        </p:txBody>
-      </p:sp>
-      <p:sp>
-        <p:nvSpPr>
-          <p:cNvPr id="12" name="TextBox 11"/>
+              <a:t>1</a:t>
+            </a:r>
+          </a:p>
+        </p:txBody>
+      </p:sp>
+      <p:sp>
+        <p:nvSpPr>
+          <p:cNvPr id="13" name="TextBox 12"/>
           <p:cNvSpPr txBox="1"/>
           <p:nvPr/>
         </p:nvSpPr>
         <p:spPr>
           <a:xfrm>
-            <a:off x="3749039" y="1920240"/>
-            <a:ext cx="7132320" cy="685800"/>
+            <a:off x="2758744" y="1810512"/>
+            <a:ext cx="7772400" cy="502920"/>
           </a:xfrm>
           <a:prstGeom prst="rect">
             <a:avLst/>
@@ -5111,27 +4888,70 @@
               </a:spcAft>
             </a:pPr>
             <a:r>
-              <a:rPr sz="2200" b="0">
+              <a:rPr sz="2400" b="0">
                 <a:solidFill>
                   <a:srgbClr val="502814"/>
                 </a:solidFill>
                 <a:latin typeface="Microsoft YaHei"/>
               </a:rPr>
-              <a:t>机敏善变、好胜不屈，追求自由（证据：连续变化、不肯认输）</a:t>
-            </a:r>
-          </a:p>
-        </p:txBody>
-      </p:sp>
-      <p:sp>
-        <p:nvSpPr>
-          <p:cNvPr id="13" name="TextBox 12"/>
+              <a:t>默读课文，圈出每次「变作」对象，标序号</a:t>
+            </a:r>
+          </a:p>
+        </p:txBody>
+      </p:sp>
+      <p:sp>
+        <p:nvSpPr>
+          <p:cNvPr id="14" name="Oval 13"/>
+          <p:cNvSpPr/>
+          <p:nvPr/>
+        </p:nvSpPr>
+        <p:spPr>
+          <a:xfrm>
+            <a:off x="2255824" y="2395728"/>
+            <a:ext cx="384048" cy="384048"/>
+          </a:xfrm>
+          <a:prstGeom prst="ellipse">
+            <a:avLst/>
+          </a:prstGeom>
+          <a:solidFill>
+            <a:srgbClr val="DC5028"/>
+          </a:solidFill>
+          <a:ln>
+            <a:noFill/>
+          </a:ln>
+        </p:spPr>
+        <p:style>
+          <a:lnRef idx="1">
+            <a:schemeClr val="accent1"/>
+          </a:lnRef>
+          <a:fillRef idx="3">
+            <a:schemeClr val="accent1"/>
+          </a:fillRef>
+          <a:effectRef idx="2">
+            <a:schemeClr val="accent1"/>
+          </a:effectRef>
+          <a:fontRef idx="minor">
+            <a:schemeClr val="lt1"/>
+          </a:fontRef>
+        </p:style>
+        <p:txBody>
+          <a:bodyPr rtlCol="0" anchor="ctr"/>
+          <a:lstStyle/>
+          <a:p>
+            <a:pPr algn="ctr"/>
+          </a:p>
+        </p:txBody>
+      </p:sp>
+      <p:sp>
+        <p:nvSpPr>
+          <p:cNvPr id="15" name="TextBox 14"/>
           <p:cNvSpPr txBox="1"/>
           <p:nvPr/>
         </p:nvSpPr>
         <p:spPr>
           <a:xfrm>
-            <a:off x="1463040" y="2670048"/>
-            <a:ext cx="2103120" cy="502920"/>
+            <a:off x="2255824" y="2414016"/>
+            <a:ext cx="384048" cy="365760"/>
           </a:xfrm>
           <a:prstGeom prst="rect">
             <a:avLst/>
@@ -5144,33 +4964,33 @@
           </a:bodyPr>
           <a:lstStyle/>
           <a:p>
-            <a:pPr algn="r">
+            <a:pPr algn="ctr">
               <a:spcAft>
                 <a:spcPts val="1000"/>
               </a:spcAft>
             </a:pPr>
             <a:r>
-              <a:rPr sz="2200" b="1">
+              <a:rPr sz="1600" b="1">
                 <a:solidFill>
-                  <a:srgbClr val="DC5028"/>
+                  <a:srgbClr val="FFFFFF"/>
                 </a:solidFill>
                 <a:latin typeface="Microsoft YaHei"/>
               </a:rPr>
-              <a:t>二郎神</a:t>
-            </a:r>
-          </a:p>
-        </p:txBody>
-      </p:sp>
-      <p:sp>
-        <p:nvSpPr>
-          <p:cNvPr id="14" name="TextBox 13"/>
+              <a:t>2</a:t>
+            </a:r>
+          </a:p>
+        </p:txBody>
+      </p:sp>
+      <p:sp>
+        <p:nvSpPr>
+          <p:cNvPr id="16" name="TextBox 15"/>
           <p:cNvSpPr txBox="1"/>
           <p:nvPr/>
         </p:nvSpPr>
         <p:spPr>
           <a:xfrm>
-            <a:off x="3749039" y="2670048"/>
-            <a:ext cx="7132320" cy="685800"/>
+            <a:off x="2758744" y="2377440"/>
+            <a:ext cx="7772400" cy="502920"/>
           </a:xfrm>
           <a:prstGeom prst="rect">
             <a:avLst/>
@@ -5189,27 +5009,70 @@
               </a:spcAft>
             </a:pPr>
             <a:r>
-              <a:rPr sz="2200" b="0">
+              <a:rPr sz="2400" b="0">
                 <a:solidFill>
                   <a:srgbClr val="502814"/>
                 </a:solidFill>
                 <a:latin typeface="Microsoft YaHei"/>
               </a:rPr>
-              <a:t>沉着冷静、法力高强，维护天庭秩序（证据：紧追不舍、识破破绽）</a:t>
-            </a:r>
-          </a:p>
-        </p:txBody>
-      </p:sp>
-      <p:sp>
-        <p:nvSpPr>
-          <p:cNvPr id="15" name="TextBox 14"/>
+              <a:t>填写七十二变对照表（孙悟空先变—二郎神相克）</a:t>
+            </a:r>
+          </a:p>
+        </p:txBody>
+      </p:sp>
+      <p:sp>
+        <p:nvSpPr>
+          <p:cNvPr id="17" name="Oval 16"/>
+          <p:cNvSpPr/>
+          <p:nvPr/>
+        </p:nvSpPr>
+        <p:spPr>
+          <a:xfrm>
+            <a:off x="2255824" y="2962656"/>
+            <a:ext cx="384048" cy="384048"/>
+          </a:xfrm>
+          <a:prstGeom prst="ellipse">
+            <a:avLst/>
+          </a:prstGeom>
+          <a:solidFill>
+            <a:srgbClr val="DC5028"/>
+          </a:solidFill>
+          <a:ln>
+            <a:noFill/>
+          </a:ln>
+        </p:spPr>
+        <p:style>
+          <a:lnRef idx="1">
+            <a:schemeClr val="accent1"/>
+          </a:lnRef>
+          <a:fillRef idx="3">
+            <a:schemeClr val="accent1"/>
+          </a:fillRef>
+          <a:effectRef idx="2">
+            <a:schemeClr val="accent1"/>
+          </a:effectRef>
+          <a:fontRef idx="minor">
+            <a:schemeClr val="lt1"/>
+          </a:fontRef>
+        </p:style>
+        <p:txBody>
+          <a:bodyPr rtlCol="0" anchor="ctr"/>
+          <a:lstStyle/>
+          <a:p>
+            <a:pPr algn="ctr"/>
+          </a:p>
+        </p:txBody>
+      </p:sp>
+      <p:sp>
+        <p:nvSpPr>
+          <p:cNvPr id="18" name="TextBox 17"/>
           <p:cNvSpPr txBox="1"/>
           <p:nvPr/>
         </p:nvSpPr>
         <p:spPr>
           <a:xfrm>
-            <a:off x="1463040" y="3419856"/>
-            <a:ext cx="2103120" cy="502920"/>
+            <a:off x="2255824" y="2980944"/>
+            <a:ext cx="384048" cy="365760"/>
           </a:xfrm>
           <a:prstGeom prst="rect">
             <a:avLst/>
@@ -5222,33 +5085,33 @@
           </a:bodyPr>
           <a:lstStyle/>
           <a:p>
-            <a:pPr algn="r">
+            <a:pPr algn="ctr">
               <a:spcAft>
                 <a:spcPts val="1000"/>
               </a:spcAft>
             </a:pPr>
             <a:r>
-              <a:rPr sz="2200" b="1">
+              <a:rPr sz="1600" b="1">
                 <a:solidFill>
-                  <a:srgbClr val="DC5028"/>
+                  <a:srgbClr val="FFFFFF"/>
                 </a:solidFill>
                 <a:latin typeface="Microsoft YaHei"/>
               </a:rPr>
-              <a:t>分析方法</a:t>
-            </a:r>
-          </a:p>
-        </p:txBody>
-      </p:sp>
-      <p:sp>
-        <p:nvSpPr>
-          <p:cNvPr id="16" name="TextBox 15"/>
+              <a:t>3</a:t>
+            </a:r>
+          </a:p>
+        </p:txBody>
+      </p:sp>
+      <p:sp>
+        <p:nvSpPr>
+          <p:cNvPr id="19" name="TextBox 18"/>
           <p:cNvSpPr txBox="1"/>
           <p:nvPr/>
         </p:nvSpPr>
         <p:spPr>
           <a:xfrm>
-            <a:off x="3749039" y="3419856"/>
-            <a:ext cx="7132320" cy="685800"/>
+            <a:off x="2758744" y="2944368"/>
+            <a:ext cx="7772400" cy="502920"/>
           </a:xfrm>
           <a:prstGeom prst="rect">
             <a:avLst/>
@@ -5267,91 +5130,13 @@
               </a:spcAft>
             </a:pPr>
             <a:r>
-              <a:rPr sz="2200" b="0">
+              <a:rPr sz="2400" b="0">
                 <a:solidFill>
                   <a:srgbClr val="502814"/>
                 </a:solidFill>
                 <a:latin typeface="Microsoft YaHei"/>
               </a:rPr>
-              <a:t>证据—特点—作用：找细节→概括性格→联系主题</a:t>
-            </a:r>
-          </a:p>
-        </p:txBody>
-      </p:sp>
-      <p:sp>
-        <p:nvSpPr>
-          <p:cNvPr id="17" name="TextBox 16"/>
-          <p:cNvSpPr txBox="1"/>
-          <p:nvPr/>
-        </p:nvSpPr>
-        <p:spPr>
-          <a:xfrm>
-            <a:off x="1463040" y="4169664"/>
-            <a:ext cx="2103120" cy="502920"/>
-          </a:xfrm>
-          <a:prstGeom prst="rect">
-            <a:avLst/>
-          </a:prstGeom>
-          <a:noFill/>
-        </p:spPr>
-        <p:txBody>
-          <a:bodyPr wrap="none">
-            <a:spAutoFit/>
-          </a:bodyPr>
-          <a:lstStyle/>
-          <a:p>
-            <a:pPr algn="r">
-              <a:spcAft>
-                <a:spcPts val="1000"/>
-              </a:spcAft>
-            </a:pPr>
-            <a:r>
-              <a:rPr sz="2200" b="1">
-                <a:solidFill>
-                  <a:srgbClr val="DC5028"/>
-                </a:solidFill>
-                <a:latin typeface="Microsoft YaHei"/>
-              </a:rPr>
-              <a:t>变旗竿</a:t>
-            </a:r>
-          </a:p>
-        </p:txBody>
-      </p:sp>
-      <p:sp>
-        <p:nvSpPr>
-          <p:cNvPr id="18" name="TextBox 17"/>
-          <p:cNvSpPr txBox="1"/>
-          <p:nvPr/>
-        </p:nvSpPr>
-        <p:spPr>
-          <a:xfrm>
-            <a:off x="3749039" y="4169664"/>
-            <a:ext cx="7132320" cy="685800"/>
-          </a:xfrm>
-          <a:prstGeom prst="rect">
-            <a:avLst/>
-          </a:prstGeom>
-          <a:noFill/>
-        </p:spPr>
-        <p:txBody>
-          <a:bodyPr wrap="none">
-            <a:spAutoFit/>
-          </a:bodyPr>
-          <a:lstStyle/>
-          <a:p>
-            <a:pPr algn="l">
-              <a:spcAft>
-                <a:spcPts val="1000"/>
-              </a:spcAft>
-            </a:pPr>
-            <a:r>
-              <a:rPr sz="2200" b="0">
-                <a:solidFill>
-                  <a:srgbClr val="502814"/>
-                </a:solidFill>
-                <a:latin typeface="Microsoft YaHei"/>
-              </a:rPr>
-              <a:t>紧张又好笑——神通广大也有露馅之时</a:t>
+              <a:t>用「孙悟空先……，二郎神便……」复述最精彩一轮</a:t>
             </a:r>
           </a:p>
         </p:txBody>
@@ -5566,7 +5351,7 @@
                 </a:solidFill>
                 <a:latin typeface="Microsoft YaHei"/>
               </a:rPr>
-              <a:t>主题笔记</a:t>
+              <a:t>加解说词</a:t>
             </a:r>
           </a:p>
         </p:txBody>
@@ -5579,7 +5364,7 @@
         </p:nvSpPr>
         <p:spPr>
           <a:xfrm>
-            <a:off x="1371600" y="1051560"/>
+            <a:off x="1371600" y="960120"/>
             <a:ext cx="9418320" cy="822960"/>
           </a:xfrm>
           <a:prstGeom prst="rect">
@@ -5605,7 +5390,7 @@
                 </a:solidFill>
                 <a:latin typeface="Microsoft YaHei"/>
               </a:rPr>
-              <a:t>名家点评</a:t>
+              <a:t>学习任务二</a:t>
             </a:r>
           </a:p>
         </p:txBody>
@@ -5618,7 +5403,7 @@
         </p:nvSpPr>
         <p:spPr>
           <a:xfrm>
-            <a:off x="3200400" y="1691640"/>
+            <a:off x="3200400" y="1600200"/>
             <a:ext cx="5760720" cy="27432"/>
           </a:xfrm>
           <a:prstGeom prst="rect">
@@ -5661,8 +5446,8 @@
         </p:nvSpPr>
         <p:spPr>
           <a:xfrm>
-            <a:off x="1249984" y="1810512"/>
-            <a:ext cx="9692640" cy="3319272"/>
+            <a:off x="1295704" y="1645920"/>
+            <a:ext cx="9601200" cy="2240280"/>
           </a:xfrm>
           <a:prstGeom prst="roundRect">
             <a:avLst/>
@@ -5700,14 +5485,57 @@
       </p:sp>
       <p:sp>
         <p:nvSpPr>
-          <p:cNvPr id="11" name="TextBox 10"/>
+          <p:cNvPr id="11" name="Oval 10"/>
+          <p:cNvSpPr/>
+          <p:nvPr/>
+        </p:nvSpPr>
+        <p:spPr>
+          <a:xfrm>
+            <a:off x="2255824" y="1828800"/>
+            <a:ext cx="384048" cy="384048"/>
+          </a:xfrm>
+          <a:prstGeom prst="ellipse">
+            <a:avLst/>
+          </a:prstGeom>
+          <a:solidFill>
+            <a:srgbClr val="DC5028"/>
+          </a:solidFill>
+          <a:ln>
+            <a:noFill/>
+          </a:ln>
+        </p:spPr>
+        <p:style>
+          <a:lnRef idx="1">
+            <a:schemeClr val="accent1"/>
+          </a:lnRef>
+          <a:fillRef idx="3">
+            <a:schemeClr val="accent1"/>
+          </a:fillRef>
+          <a:effectRef idx="2">
+            <a:schemeClr val="accent1"/>
+          </a:effectRef>
+          <a:fontRef idx="minor">
+            <a:schemeClr val="lt1"/>
+          </a:fontRef>
+        </p:style>
+        <p:txBody>
+          <a:bodyPr rtlCol="0" anchor="ctr"/>
+          <a:lstStyle/>
+          <a:p>
+            <a:pPr algn="ctr"/>
+          </a:p>
+        </p:txBody>
+      </p:sp>
+      <p:sp>
+        <p:nvSpPr>
+          <p:cNvPr id="12" name="TextBox 11"/>
           <p:cNvSpPr txBox="1"/>
           <p:nvPr/>
         </p:nvSpPr>
         <p:spPr>
           <a:xfrm>
-            <a:off x="1463040" y="1920240"/>
-            <a:ext cx="2103120" cy="502920"/>
+            <a:off x="2255824" y="1847088"/>
+            <a:ext cx="384048" cy="365760"/>
           </a:xfrm>
           <a:prstGeom prst="rect">
             <a:avLst/>
@@ -5720,33 +5548,33 @@
           </a:bodyPr>
           <a:lstStyle/>
           <a:p>
-            <a:pPr algn="r">
+            <a:pPr algn="ctr">
               <a:spcAft>
                 <a:spcPts val="1000"/>
               </a:spcAft>
             </a:pPr>
             <a:r>
-              <a:rPr sz="2200" b="1">
+              <a:rPr sz="1600" b="1">
                 <a:solidFill>
-                  <a:srgbClr val="DC5028"/>
+                  <a:srgbClr val="FFFFFF"/>
                 </a:solidFill>
                 <a:latin typeface="Microsoft YaHei"/>
               </a:rPr>
-              <a:t>鲁迅</a:t>
-            </a:r>
-          </a:p>
-        </p:txBody>
-      </p:sp>
-      <p:sp>
-        <p:nvSpPr>
-          <p:cNvPr id="12" name="TextBox 11"/>
+              <a:t>1</a:t>
+            </a:r>
+          </a:p>
+        </p:txBody>
+      </p:sp>
+      <p:sp>
+        <p:nvSpPr>
+          <p:cNvPr id="13" name="TextBox 12"/>
           <p:cNvSpPr txBox="1"/>
           <p:nvPr/>
         </p:nvSpPr>
         <p:spPr>
           <a:xfrm>
-            <a:off x="3749039" y="1920240"/>
-            <a:ext cx="7132320" cy="685800"/>
+            <a:off x="2758744" y="1810512"/>
+            <a:ext cx="7772400" cy="502920"/>
           </a:xfrm>
           <a:prstGeom prst="rect">
             <a:avLst/>
@@ -5765,27 +5593,70 @@
               </a:spcAft>
             </a:pPr>
             <a:r>
-              <a:rPr sz="2200" b="0">
+              <a:rPr sz="2400" b="0">
                 <a:solidFill>
                   <a:srgbClr val="502814"/>
                 </a:solidFill>
                 <a:latin typeface="Microsoft YaHei"/>
               </a:rPr>
-              <a:t>「使神魔皆有人情，精魅亦通世故」——神魔也有人的情感</a:t>
-            </a:r>
-          </a:p>
-        </p:txBody>
-      </p:sp>
-      <p:sp>
-        <p:nvSpPr>
-          <p:cNvPr id="13" name="TextBox 12"/>
+              <a:t>变庙宇：尾巴为何变旗竿？写一句批注</a:t>
+            </a:r>
+          </a:p>
+        </p:txBody>
+      </p:sp>
+      <p:sp>
+        <p:nvSpPr>
+          <p:cNvPr id="14" name="Oval 13"/>
+          <p:cNvSpPr/>
+          <p:nvPr/>
+        </p:nvSpPr>
+        <p:spPr>
+          <a:xfrm>
+            <a:off x="2255824" y="2395728"/>
+            <a:ext cx="384048" cy="384048"/>
+          </a:xfrm>
+          <a:prstGeom prst="ellipse">
+            <a:avLst/>
+          </a:prstGeom>
+          <a:solidFill>
+            <a:srgbClr val="DC5028"/>
+          </a:solidFill>
+          <a:ln>
+            <a:noFill/>
+          </a:ln>
+        </p:spPr>
+        <p:style>
+          <a:lnRef idx="1">
+            <a:schemeClr val="accent1"/>
+          </a:lnRef>
+          <a:fillRef idx="3">
+            <a:schemeClr val="accent1"/>
+          </a:fillRef>
+          <a:effectRef idx="2">
+            <a:schemeClr val="accent1"/>
+          </a:effectRef>
+          <a:fontRef idx="minor">
+            <a:schemeClr val="lt1"/>
+          </a:fontRef>
+        </p:style>
+        <p:txBody>
+          <a:bodyPr rtlCol="0" anchor="ctr"/>
+          <a:lstStyle/>
+          <a:p>
+            <a:pPr algn="ctr"/>
+          </a:p>
+        </p:txBody>
+      </p:sp>
+      <p:sp>
+        <p:nvSpPr>
+          <p:cNvPr id="15" name="TextBox 14"/>
           <p:cNvSpPr txBox="1"/>
           <p:nvPr/>
         </p:nvSpPr>
         <p:spPr>
           <a:xfrm>
-            <a:off x="1463040" y="2670048"/>
-            <a:ext cx="2103120" cy="502920"/>
+            <a:off x="2255824" y="2414016"/>
+            <a:ext cx="384048" cy="365760"/>
           </a:xfrm>
           <a:prstGeom prst="rect">
             <a:avLst/>
@@ -5798,33 +5669,33 @@
           </a:bodyPr>
           <a:lstStyle/>
           <a:p>
-            <a:pPr algn="r">
+            <a:pPr algn="ctr">
               <a:spcAft>
                 <a:spcPts val="1000"/>
               </a:spcAft>
             </a:pPr>
             <a:r>
-              <a:rPr sz="2200" b="1">
+              <a:rPr sz="1600" b="1">
                 <a:solidFill>
-                  <a:srgbClr val="DC5028"/>
+                  <a:srgbClr val="FFFFFF"/>
                 </a:solidFill>
                 <a:latin typeface="Microsoft YaHei"/>
               </a:rPr>
-              <a:t>林庚</a:t>
-            </a:r>
-          </a:p>
-        </p:txBody>
-      </p:sp>
-      <p:sp>
-        <p:nvSpPr>
-          <p:cNvPr id="14" name="TextBox 13"/>
+              <a:t>2</a:t>
+            </a:r>
+          </a:p>
+        </p:txBody>
+      </p:sp>
+      <p:sp>
+        <p:nvSpPr>
+          <p:cNvPr id="16" name="TextBox 15"/>
           <p:cNvSpPr txBox="1"/>
           <p:nvPr/>
         </p:nvSpPr>
         <p:spPr>
           <a:xfrm>
-            <a:off x="3749039" y="2670048"/>
-            <a:ext cx="7132320" cy="685800"/>
+            <a:off x="2758744" y="2377440"/>
+            <a:ext cx="7772400" cy="502920"/>
           </a:xfrm>
           <a:prstGeom prst="rect">
             <a:avLst/>
@@ -5843,27 +5714,70 @@
               </a:spcAft>
             </a:pPr>
             <a:r>
-              <a:rPr sz="2200" b="0">
+              <a:rPr sz="2400" b="0">
                 <a:solidFill>
                   <a:srgbClr val="502814"/>
                 </a:solidFill>
                 <a:latin typeface="Microsoft YaHei"/>
               </a:rPr>
-              <a:t>不宜看得过于认真，应看到儿童的心理与行为</a:t>
-            </a:r>
-          </a:p>
-        </p:txBody>
-      </p:sp>
-      <p:sp>
-        <p:nvSpPr>
-          <p:cNvPr id="15" name="TextBox 14"/>
+              <a:t>完成人物档案卡（证据—特点—作用）</a:t>
+            </a:r>
+          </a:p>
+        </p:txBody>
+      </p:sp>
+      <p:sp>
+        <p:nvSpPr>
+          <p:cNvPr id="17" name="Oval 16"/>
+          <p:cNvSpPr/>
+          <p:nvPr/>
+        </p:nvSpPr>
+        <p:spPr>
+          <a:xfrm>
+            <a:off x="2255824" y="2962656"/>
+            <a:ext cx="384048" cy="384048"/>
+          </a:xfrm>
+          <a:prstGeom prst="ellipse">
+            <a:avLst/>
+          </a:prstGeom>
+          <a:solidFill>
+            <a:srgbClr val="DC5028"/>
+          </a:solidFill>
+          <a:ln>
+            <a:noFill/>
+          </a:ln>
+        </p:spPr>
+        <p:style>
+          <a:lnRef idx="1">
+            <a:schemeClr val="accent1"/>
+          </a:lnRef>
+          <a:fillRef idx="3">
+            <a:schemeClr val="accent1"/>
+          </a:fillRef>
+          <a:effectRef idx="2">
+            <a:schemeClr val="accent1"/>
+          </a:effectRef>
+          <a:fontRef idx="minor">
+            <a:schemeClr val="lt1"/>
+          </a:fontRef>
+        </p:style>
+        <p:txBody>
+          <a:bodyPr rtlCol="0" anchor="ctr"/>
+          <a:lstStyle/>
+          <a:p>
+            <a:pPr algn="ctr"/>
+          </a:p>
+        </p:txBody>
+      </p:sp>
+      <p:sp>
+        <p:nvSpPr>
+          <p:cNvPr id="18" name="TextBox 17"/>
           <p:cNvSpPr txBox="1"/>
           <p:nvPr/>
         </p:nvSpPr>
         <p:spPr>
           <a:xfrm>
-            <a:off x="1463040" y="3419856"/>
-            <a:ext cx="2103120" cy="502920"/>
+            <a:off x="2255824" y="2980944"/>
+            <a:ext cx="384048" cy="365760"/>
           </a:xfrm>
           <a:prstGeom prst="rect">
             <a:avLst/>
@@ -5876,33 +5790,33 @@
           </a:bodyPr>
           <a:lstStyle/>
           <a:p>
-            <a:pPr algn="r">
+            <a:pPr algn="ctr">
               <a:spcAft>
                 <a:spcPts val="1000"/>
               </a:spcAft>
             </a:pPr>
             <a:r>
-              <a:rPr sz="2200" b="1">
+              <a:rPr sz="1600" b="1">
                 <a:solidFill>
-                  <a:srgbClr val="DC5028"/>
+                  <a:srgbClr val="FFFFFF"/>
                 </a:solidFill>
                 <a:latin typeface="Microsoft YaHei"/>
               </a:rPr>
-              <a:t>艺术特色</a:t>
-            </a:r>
-          </a:p>
-        </p:txBody>
-      </p:sp>
-      <p:sp>
-        <p:nvSpPr>
-          <p:cNvPr id="16" name="TextBox 15"/>
+              <a:t>3</a:t>
+            </a:r>
+          </a:p>
+        </p:txBody>
+      </p:sp>
+      <p:sp>
+        <p:nvSpPr>
+          <p:cNvPr id="19" name="TextBox 18"/>
           <p:cNvSpPr txBox="1"/>
           <p:nvPr/>
         </p:nvSpPr>
         <p:spPr>
           <a:xfrm>
-            <a:off x="3749039" y="3419856"/>
-            <a:ext cx="7132320" cy="685800"/>
+            <a:off x="2758744" y="2944368"/>
+            <a:ext cx="7772400" cy="502920"/>
           </a:xfrm>
           <a:prstGeom prst="rect">
             <a:avLst/>
@@ -5921,91 +5835,13 @@
               </a:spcAft>
             </a:pPr>
             <a:r>
-              <a:rPr sz="2200" b="0">
+              <a:rPr sz="2400" b="0">
                 <a:solidFill>
                   <a:srgbClr val="502814"/>
                 </a:solidFill>
                 <a:latin typeface="Microsoft YaHei"/>
               </a:rPr>
-              <a:t>想象基于「相克」逻辑，变化链环环相扣</a:t>
-            </a:r>
-          </a:p>
-        </p:txBody>
-      </p:sp>
-      <p:sp>
-        <p:nvSpPr>
-          <p:cNvPr id="17" name="TextBox 16"/>
-          <p:cNvSpPr txBox="1"/>
-          <p:nvPr/>
-        </p:nvSpPr>
-        <p:spPr>
-          <a:xfrm>
-            <a:off x="1463040" y="4169664"/>
-            <a:ext cx="2103120" cy="502920"/>
-          </a:xfrm>
-          <a:prstGeom prst="rect">
-            <a:avLst/>
-          </a:prstGeom>
-          <a:noFill/>
-        </p:spPr>
-        <p:txBody>
-          <a:bodyPr wrap="none">
-            <a:spAutoFit/>
-          </a:bodyPr>
-          <a:lstStyle/>
-          <a:p>
-            <a:pPr algn="r">
-              <a:spcAft>
-                <a:spcPts val="1000"/>
-              </a:spcAft>
-            </a:pPr>
-            <a:r>
-              <a:rPr sz="2200" b="1">
-                <a:solidFill>
-                  <a:srgbClr val="DC5028"/>
-                </a:solidFill>
-                <a:latin typeface="Microsoft YaHei"/>
-              </a:rPr>
-              <a:t>策展主题</a:t>
-            </a:r>
-          </a:p>
-        </p:txBody>
-      </p:sp>
-      <p:sp>
-        <p:nvSpPr>
-          <p:cNvPr id="18" name="TextBox 17"/>
-          <p:cNvSpPr txBox="1"/>
-          <p:nvPr/>
-        </p:nvSpPr>
-        <p:spPr>
-          <a:xfrm>
-            <a:off x="3749039" y="4169664"/>
-            <a:ext cx="7132320" cy="685800"/>
-          </a:xfrm>
-          <a:prstGeom prst="rect">
-            <a:avLst/>
-          </a:prstGeom>
-          <a:noFill/>
-        </p:spPr>
-        <p:txBody>
-          <a:bodyPr wrap="none">
-            <a:spAutoFit/>
-          </a:bodyPr>
-          <a:lstStyle/>
-          <a:p>
-            <a:pPr algn="l">
-              <a:spcAft>
-                <a:spcPts val="1000"/>
-              </a:spcAft>
-            </a:pPr>
-            <a:r>
-              <a:rPr sz="2200" b="0">
-                <a:solidFill>
-                  <a:srgbClr val="502814"/>
-                </a:solidFill>
-                <a:latin typeface="Microsoft YaHei"/>
-              </a:rPr>
-              <a:t>自由可贵，但不可无视规则（自由与规则）</a:t>
+              <a:t>批注鲁迅、林庚的评论，找「人情」与「世故」</a:t>
             </a:r>
           </a:p>
         </p:txBody>
@@ -6151,7 +5987,7 @@
         </p:nvSpPr>
         <p:spPr>
           <a:xfrm>
-            <a:off x="4953304" y="502920"/>
+            <a:off x="4953304" y="1005840"/>
             <a:ext cx="2286000" cy="411480"/>
           </a:xfrm>
           <a:prstGeom prst="roundRect">
@@ -6194,7 +6030,7 @@
         </p:nvSpPr>
         <p:spPr>
           <a:xfrm>
-            <a:off x="4953304" y="521208"/>
+            <a:off x="4953304" y="1024128"/>
             <a:ext cx="2286000" cy="384048"/>
           </a:xfrm>
           <a:prstGeom prst="rect">
@@ -6220,7 +6056,7 @@
                 </a:solidFill>
                 <a:latin typeface="Microsoft YaHei"/>
               </a:rPr>
-              <a:t>课堂活动</a:t>
+              <a:t>想一想</a:t>
             </a:r>
           </a:p>
         </p:txBody>
@@ -6233,7 +6069,7 @@
         </p:nvSpPr>
         <p:spPr>
           <a:xfrm>
-            <a:off x="1371600" y="1051560"/>
+            <a:off x="1371600" y="1600200"/>
             <a:ext cx="9418320" cy="822960"/>
           </a:xfrm>
           <a:prstGeom prst="rect">
@@ -6253,13 +6089,14 @@
               </a:spcAft>
             </a:pPr>
             <a:r>
-              <a:rPr sz="3600" b="1">
+              <a:rPr sz="3200" b="1">
                 <a:solidFill>
                   <a:srgbClr val="DC5028"/>
                 </a:solidFill>
                 <a:latin typeface="Microsoft YaHei"/>
               </a:rPr>
-              <a:t>学习任务</a:t>
+              <a:t>「使神魔皆有人情，精魅亦通世故」
+课文哪里体现了人情与世故？</a:t>
             </a:r>
           </a:p>
         </p:txBody>
@@ -6272,7 +6109,7 @@
         </p:nvSpPr>
         <p:spPr>
           <a:xfrm>
-            <a:off x="3200400" y="1691640"/>
+            <a:off x="3200400" y="4389120"/>
             <a:ext cx="5760720" cy="27432"/>
           </a:xfrm>
           <a:prstGeom prst="rect">
@@ -6309,102 +6146,14 @@
       </p:sp>
       <p:sp>
         <p:nvSpPr>
-          <p:cNvPr id="10" name="Rounded Rectangle 9"/>
-          <p:cNvSpPr/>
-          <p:nvPr/>
-        </p:nvSpPr>
-        <p:spPr>
-          <a:xfrm>
-            <a:off x="1295704" y="1737360"/>
-            <a:ext cx="9601200" cy="2112264"/>
-          </a:xfrm>
-          <a:prstGeom prst="roundRect">
-            <a:avLst/>
-          </a:prstGeom>
-          <a:solidFill>
-            <a:srgbClr val="FFF8F0"/>
-          </a:solidFill>
-          <a:ln w="19050">
-            <a:solidFill>
-              <a:srgbClr val="FFB464"/>
-            </a:solidFill>
-          </a:ln>
-        </p:spPr>
-        <p:style>
-          <a:lnRef idx="1">
-            <a:schemeClr val="accent1"/>
-          </a:lnRef>
-          <a:fillRef idx="3">
-            <a:schemeClr val="accent1"/>
-          </a:fillRef>
-          <a:effectRef idx="2">
-            <a:schemeClr val="accent1"/>
-          </a:effectRef>
-          <a:fontRef idx="minor">
-            <a:schemeClr val="lt1"/>
-          </a:fontRef>
-        </p:style>
-        <p:txBody>
-          <a:bodyPr rtlCol="0" anchor="ctr"/>
-          <a:lstStyle/>
-          <a:p>
-            <a:pPr algn="ctr"/>
-          </a:p>
-        </p:txBody>
-      </p:sp>
-      <p:sp>
-        <p:nvSpPr>
-          <p:cNvPr id="11" name="Oval 10"/>
-          <p:cNvSpPr/>
-          <p:nvPr/>
-        </p:nvSpPr>
-        <p:spPr>
-          <a:xfrm>
-            <a:off x="2621584" y="1920240"/>
-            <a:ext cx="347472" cy="347472"/>
-          </a:xfrm>
-          <a:prstGeom prst="ellipse">
-            <a:avLst/>
-          </a:prstGeom>
-          <a:solidFill>
-            <a:srgbClr val="DC5028"/>
-          </a:solidFill>
-          <a:ln>
-            <a:noFill/>
-          </a:ln>
-        </p:spPr>
-        <p:style>
-          <a:lnRef idx="1">
-            <a:schemeClr val="accent1"/>
-          </a:lnRef>
-          <a:fillRef idx="3">
-            <a:schemeClr val="accent1"/>
-          </a:fillRef>
-          <a:effectRef idx="2">
-            <a:schemeClr val="accent1"/>
-          </a:effectRef>
-          <a:fontRef idx="minor">
-            <a:schemeClr val="lt1"/>
-          </a:fontRef>
-        </p:style>
-        <p:txBody>
-          <a:bodyPr rtlCol="0" anchor="ctr"/>
-          <a:lstStyle/>
-          <a:p>
-            <a:pPr algn="ctr"/>
-          </a:p>
-        </p:txBody>
-      </p:sp>
-      <p:sp>
-        <p:nvSpPr>
-          <p:cNvPr id="12" name="TextBox 11"/>
+          <p:cNvPr id="10" name="TextBox 9"/>
           <p:cNvSpPr txBox="1"/>
           <p:nvPr/>
         </p:nvSpPr>
         <p:spPr>
           <a:xfrm>
-            <a:off x="2621584" y="1938528"/>
-            <a:ext cx="347472" cy="329184"/>
+            <a:off x="1828800" y="4663440"/>
+            <a:ext cx="8503920" cy="914400"/>
           </a:xfrm>
           <a:prstGeom prst="rect">
             <a:avLst/>
@@ -6423,294 +6172,13 @@
               </a:spcAft>
             </a:pPr>
             <a:r>
-              <a:rPr sz="1400" b="1">
+              <a:rPr sz="2200" b="0">
                 <a:solidFill>
-                  <a:srgbClr val="FFFFFF"/>
+                  <a:srgbClr val="DC5028"/>
                 </a:solidFill>
                 <a:latin typeface="Microsoft YaHei"/>
               </a:rPr>
-              <a:t>1</a:t>
-            </a:r>
-          </a:p>
-        </p:txBody>
-      </p:sp>
-      <p:sp>
-        <p:nvSpPr>
-          <p:cNvPr id="13" name="TextBox 12"/>
-          <p:cNvSpPr txBox="1"/>
-          <p:nvPr/>
-        </p:nvSpPr>
-        <p:spPr>
-          <a:xfrm>
-            <a:off x="3078784" y="1901952"/>
-            <a:ext cx="7863840" cy="457200"/>
-          </a:xfrm>
-          <a:prstGeom prst="rect">
-            <a:avLst/>
-          </a:prstGeom>
-          <a:noFill/>
-        </p:spPr>
-        <p:txBody>
-          <a:bodyPr wrap="none">
-            <a:spAutoFit/>
-          </a:bodyPr>
-          <a:lstStyle/>
-          <a:p>
-            <a:pPr algn="l">
-              <a:spcAft>
-                <a:spcPts val="1000"/>
-              </a:spcAft>
-            </a:pPr>
-            <a:r>
-              <a:rPr sz="2400" b="0">
-                <a:solidFill>
-                  <a:srgbClr val="502814"/>
-                </a:solidFill>
-                <a:latin typeface="Microsoft YaHei"/>
-              </a:rPr>
-              <a:t>填写七十二变对照表，标出相克关系</a:t>
-            </a:r>
-          </a:p>
-        </p:txBody>
-      </p:sp>
-      <p:sp>
-        <p:nvSpPr>
-          <p:cNvPr id="14" name="Oval 13"/>
-          <p:cNvSpPr/>
-          <p:nvPr/>
-        </p:nvSpPr>
-        <p:spPr>
-          <a:xfrm>
-            <a:off x="2621584" y="2487168"/>
-            <a:ext cx="347472" cy="347472"/>
-          </a:xfrm>
-          <a:prstGeom prst="ellipse">
-            <a:avLst/>
-          </a:prstGeom>
-          <a:solidFill>
-            <a:srgbClr val="DC5028"/>
-          </a:solidFill>
-          <a:ln>
-            <a:noFill/>
-          </a:ln>
-        </p:spPr>
-        <p:style>
-          <a:lnRef idx="1">
-            <a:schemeClr val="accent1"/>
-          </a:lnRef>
-          <a:fillRef idx="3">
-            <a:schemeClr val="accent1"/>
-          </a:fillRef>
-          <a:effectRef idx="2">
-            <a:schemeClr val="accent1"/>
-          </a:effectRef>
-          <a:fontRef idx="minor">
-            <a:schemeClr val="lt1"/>
-          </a:fontRef>
-        </p:style>
-        <p:txBody>
-          <a:bodyPr rtlCol="0" anchor="ctr"/>
-          <a:lstStyle/>
-          <a:p>
-            <a:pPr algn="ctr"/>
-          </a:p>
-        </p:txBody>
-      </p:sp>
-      <p:sp>
-        <p:nvSpPr>
-          <p:cNvPr id="15" name="TextBox 14"/>
-          <p:cNvSpPr txBox="1"/>
-          <p:nvPr/>
-        </p:nvSpPr>
-        <p:spPr>
-          <a:xfrm>
-            <a:off x="2621584" y="2505456"/>
-            <a:ext cx="347472" cy="329184"/>
-          </a:xfrm>
-          <a:prstGeom prst="rect">
-            <a:avLst/>
-          </a:prstGeom>
-          <a:noFill/>
-        </p:spPr>
-        <p:txBody>
-          <a:bodyPr wrap="none">
-            <a:spAutoFit/>
-          </a:bodyPr>
-          <a:lstStyle/>
-          <a:p>
-            <a:pPr algn="ctr">
-              <a:spcAft>
-                <a:spcPts val="1000"/>
-              </a:spcAft>
-            </a:pPr>
-            <a:r>
-              <a:rPr sz="1400" b="1">
-                <a:solidFill>
-                  <a:srgbClr val="FFFFFF"/>
-                </a:solidFill>
-                <a:latin typeface="Microsoft YaHei"/>
-              </a:rPr>
-              <a:t>2</a:t>
-            </a:r>
-          </a:p>
-        </p:txBody>
-      </p:sp>
-      <p:sp>
-        <p:nvSpPr>
-          <p:cNvPr id="16" name="TextBox 15"/>
-          <p:cNvSpPr txBox="1"/>
-          <p:nvPr/>
-        </p:nvSpPr>
-        <p:spPr>
-          <a:xfrm>
-            <a:off x="3078784" y="2468880"/>
-            <a:ext cx="7863840" cy="457200"/>
-          </a:xfrm>
-          <a:prstGeom prst="rect">
-            <a:avLst/>
-          </a:prstGeom>
-          <a:noFill/>
-        </p:spPr>
-        <p:txBody>
-          <a:bodyPr wrap="none">
-            <a:spAutoFit/>
-          </a:bodyPr>
-          <a:lstStyle/>
-          <a:p>
-            <a:pPr algn="l">
-              <a:spcAft>
-                <a:spcPts val="1000"/>
-              </a:spcAft>
-            </a:pPr>
-            <a:r>
-              <a:rPr sz="2400" b="0">
-                <a:solidFill>
-                  <a:srgbClr val="502814"/>
-                </a:solidFill>
-                <a:latin typeface="Microsoft YaHei"/>
-              </a:rPr>
-              <a:t>完成人物档案卡（证据—特点—作用）</a:t>
-            </a:r>
-          </a:p>
-        </p:txBody>
-      </p:sp>
-      <p:sp>
-        <p:nvSpPr>
-          <p:cNvPr id="17" name="Oval 16"/>
-          <p:cNvSpPr/>
-          <p:nvPr/>
-        </p:nvSpPr>
-        <p:spPr>
-          <a:xfrm>
-            <a:off x="2621584" y="3054096"/>
-            <a:ext cx="347472" cy="347472"/>
-          </a:xfrm>
-          <a:prstGeom prst="ellipse">
-            <a:avLst/>
-          </a:prstGeom>
-          <a:solidFill>
-            <a:srgbClr val="DC5028"/>
-          </a:solidFill>
-          <a:ln>
-            <a:noFill/>
-          </a:ln>
-        </p:spPr>
-        <p:style>
-          <a:lnRef idx="1">
-            <a:schemeClr val="accent1"/>
-          </a:lnRef>
-          <a:fillRef idx="3">
-            <a:schemeClr val="accent1"/>
-          </a:fillRef>
-          <a:effectRef idx="2">
-            <a:schemeClr val="accent1"/>
-          </a:effectRef>
-          <a:fontRef idx="minor">
-            <a:schemeClr val="lt1"/>
-          </a:fontRef>
-        </p:style>
-        <p:txBody>
-          <a:bodyPr rtlCol="0" anchor="ctr"/>
-          <a:lstStyle/>
-          <a:p>
-            <a:pPr algn="ctr"/>
-          </a:p>
-        </p:txBody>
-      </p:sp>
-      <p:sp>
-        <p:nvSpPr>
-          <p:cNvPr id="18" name="TextBox 17"/>
-          <p:cNvSpPr txBox="1"/>
-          <p:nvPr/>
-        </p:nvSpPr>
-        <p:spPr>
-          <a:xfrm>
-            <a:off x="2621584" y="3072384"/>
-            <a:ext cx="347472" cy="329184"/>
-          </a:xfrm>
-          <a:prstGeom prst="rect">
-            <a:avLst/>
-          </a:prstGeom>
-          <a:noFill/>
-        </p:spPr>
-        <p:txBody>
-          <a:bodyPr wrap="none">
-            <a:spAutoFit/>
-          </a:bodyPr>
-          <a:lstStyle/>
-          <a:p>
-            <a:pPr algn="ctr">
-              <a:spcAft>
-                <a:spcPts val="1000"/>
-              </a:spcAft>
-            </a:pPr>
-            <a:r>
-              <a:rPr sz="1400" b="1">
-                <a:solidFill>
-                  <a:srgbClr val="FFFFFF"/>
-                </a:solidFill>
-                <a:latin typeface="Microsoft YaHei"/>
-              </a:rPr>
-              <a:t>3</a:t>
-            </a:r>
-          </a:p>
-        </p:txBody>
-      </p:sp>
-      <p:sp>
-        <p:nvSpPr>
-          <p:cNvPr id="19" name="TextBox 18"/>
-          <p:cNvSpPr txBox="1"/>
-          <p:nvPr/>
-        </p:nvSpPr>
-        <p:spPr>
-          <a:xfrm>
-            <a:off x="3078784" y="3035808"/>
-            <a:ext cx="7863840" cy="457200"/>
-          </a:xfrm>
-          <a:prstGeom prst="rect">
-            <a:avLst/>
-          </a:prstGeom>
-          <a:noFill/>
-        </p:spPr>
-        <p:txBody>
-          <a:bodyPr wrap="none">
-            <a:spAutoFit/>
-          </a:bodyPr>
-          <a:lstStyle/>
-          <a:p>
-            <a:pPr algn="l">
-              <a:spcAft>
-                <a:spcPts val="1000"/>
-              </a:spcAft>
-            </a:pPr>
-            <a:r>
-              <a:rPr sz="2400" b="0">
-                <a:solidFill>
-                  <a:srgbClr val="502814"/>
-                </a:solidFill>
-                <a:latin typeface="Microsoft YaHei"/>
-              </a:rPr>
-              <a:t>用「孙悟空先……，二郎神便……」复述最精彩一轮</a:t>
+              <a:t>林庚：不宜看得过于认真，应看到儿童心理</a:t>
             </a:r>
           </a:p>
         </p:txBody>
@@ -6925,7 +6393,7 @@
                 </a:solidFill>
                 <a:latin typeface="Microsoft YaHei"/>
               </a:rPr>
-              <a:t>回顾收获</a:t>
+              <a:t>主题探究</a:t>
             </a:r>
           </a:p>
         </p:txBody>
@@ -6938,7 +6406,7 @@
         </p:nvSpPr>
         <p:spPr>
           <a:xfrm>
-            <a:off x="1371600" y="1051560"/>
+            <a:off x="1371600" y="960120"/>
             <a:ext cx="9418320" cy="822960"/>
           </a:xfrm>
           <a:prstGeom prst="rect">
@@ -6964,7 +6432,7 @@
                 </a:solidFill>
                 <a:latin typeface="Microsoft YaHei"/>
               </a:rPr>
-              <a:t>课堂小结</a:t>
+              <a:t>学习任务三</a:t>
             </a:r>
           </a:p>
         </p:txBody>
@@ -6977,7 +6445,7 @@
         </p:nvSpPr>
         <p:spPr>
           <a:xfrm>
-            <a:off x="3200400" y="1691640"/>
+            <a:off x="3200400" y="1600200"/>
             <a:ext cx="5760720" cy="27432"/>
           </a:xfrm>
           <a:prstGeom prst="rect">
@@ -7020,8 +6488,8 @@
         </p:nvSpPr>
         <p:spPr>
           <a:xfrm>
-            <a:off x="1295704" y="1737360"/>
-            <a:ext cx="9601200" cy="1837944"/>
+            <a:off x="1295704" y="1645920"/>
+            <a:ext cx="9601200" cy="2240280"/>
           </a:xfrm>
           <a:prstGeom prst="roundRect">
             <a:avLst/>
@@ -7065,8 +6533,8 @@
         </p:nvSpPr>
         <p:spPr>
           <a:xfrm>
-            <a:off x="2621584" y="1920240"/>
-            <a:ext cx="347472" cy="347472"/>
+            <a:off x="2255824" y="1828800"/>
+            <a:ext cx="384048" cy="384048"/>
           </a:xfrm>
           <a:prstGeom prst="ellipse">
             <a:avLst/>
@@ -7108,8 +6576,8 @@
         </p:nvSpPr>
         <p:spPr>
           <a:xfrm>
-            <a:off x="2621584" y="1938528"/>
-            <a:ext cx="347472" cy="329184"/>
+            <a:off x="2255824" y="1847088"/>
+            <a:ext cx="384048" cy="365760"/>
           </a:xfrm>
           <a:prstGeom prst="rect">
             <a:avLst/>
@@ -7128,7 +6596,7 @@
               </a:spcAft>
             </a:pPr>
             <a:r>
-              <a:rPr sz="1400" b="1">
+              <a:rPr sz="1600" b="1">
                 <a:solidFill>
                   <a:srgbClr val="FFFFFF"/>
                 </a:solidFill>
@@ -7147,8 +6615,8 @@
         </p:nvSpPr>
         <p:spPr>
           <a:xfrm>
-            <a:off x="3078784" y="1901952"/>
-            <a:ext cx="7863840" cy="457200"/>
+            <a:off x="2758744" y="1810512"/>
+            <a:ext cx="7772400" cy="502920"/>
           </a:xfrm>
           <a:prstGeom prst="rect">
             <a:avLst/>
@@ -7167,13 +6635,13 @@
               </a:spcAft>
             </a:pPr>
             <a:r>
-              <a:rPr sz="2200" b="0">
+              <a:rPr sz="2400" b="0">
                 <a:solidFill>
                   <a:srgbClr val="502814"/>
                 </a:solidFill>
                 <a:latin typeface="Microsoft YaHei"/>
               </a:rPr>
-              <a:t>神魔小说：想象在「相克」中见趣味，在斗法中见人情</a:t>
+              <a:t>讨论：孙悟空为何逃？天庭为何捉他？</a:t>
             </a:r>
           </a:p>
         </p:txBody>
@@ -7186,8 +6654,8 @@
         </p:nvSpPr>
         <p:spPr>
           <a:xfrm>
-            <a:off x="2621584" y="2395728"/>
-            <a:ext cx="347472" cy="347472"/>
+            <a:off x="2255824" y="2395728"/>
+            <a:ext cx="384048" cy="384048"/>
           </a:xfrm>
           <a:prstGeom prst="ellipse">
             <a:avLst/>
@@ -7229,8 +6697,8 @@
         </p:nvSpPr>
         <p:spPr>
           <a:xfrm>
-            <a:off x="2621584" y="2414016"/>
-            <a:ext cx="347472" cy="329184"/>
+            <a:off x="2255824" y="2414016"/>
+            <a:ext cx="384048" cy="365760"/>
           </a:xfrm>
           <a:prstGeom prst="rect">
             <a:avLst/>
@@ -7249,7 +6717,7 @@
               </a:spcAft>
             </a:pPr>
             <a:r>
-              <a:rPr sz="1400" b="1">
+              <a:rPr sz="1600" b="1">
                 <a:solidFill>
                   <a:srgbClr val="FFFFFF"/>
                 </a:solidFill>
@@ -7268,8 +6736,8 @@
         </p:nvSpPr>
         <p:spPr>
           <a:xfrm>
-            <a:off x="3078784" y="2377440"/>
-            <a:ext cx="7863840" cy="457200"/>
+            <a:off x="2758744" y="2377440"/>
+            <a:ext cx="7772400" cy="502920"/>
           </a:xfrm>
           <a:prstGeom prst="rect">
             <a:avLst/>
@@ -7288,13 +6756,13 @@
               </a:spcAft>
             </a:pPr>
             <a:r>
-              <a:rPr sz="2200" b="0">
+              <a:rPr sz="2400" b="0">
                 <a:solidFill>
                   <a:srgbClr val="502814"/>
                 </a:solidFill>
                 <a:latin typeface="Microsoft YaHei"/>
               </a:rPr>
-              <a:t>变化链是因果回应，不是随意编造</a:t>
+              <a:t>联系生活：追求自由与遵守规则矛盾吗？</a:t>
             </a:r>
           </a:p>
         </p:txBody>
@@ -7307,8 +6775,8 @@
         </p:nvSpPr>
         <p:spPr>
           <a:xfrm>
-            <a:off x="2621584" y="2871216"/>
-            <a:ext cx="347472" cy="347472"/>
+            <a:off x="2255824" y="2962656"/>
+            <a:ext cx="384048" cy="384048"/>
           </a:xfrm>
           <a:prstGeom prst="ellipse">
             <a:avLst/>
@@ -7350,8 +6818,8 @@
         </p:nvSpPr>
         <p:spPr>
           <a:xfrm>
-            <a:off x="2621584" y="2889504"/>
-            <a:ext cx="347472" cy="329184"/>
+            <a:off x="2255824" y="2980944"/>
+            <a:ext cx="384048" cy="365760"/>
           </a:xfrm>
           <a:prstGeom prst="rect">
             <a:avLst/>
@@ -7370,7 +6838,7 @@
               </a:spcAft>
             </a:pPr>
             <a:r>
-              <a:rPr sz="1400" b="1">
+              <a:rPr sz="1600" b="1">
                 <a:solidFill>
                   <a:srgbClr val="FFFFFF"/>
                 </a:solidFill>
@@ -7389,8 +6857,8 @@
         </p:nvSpPr>
         <p:spPr>
           <a:xfrm>
-            <a:off x="3078784" y="2852928"/>
-            <a:ext cx="7863840" cy="457200"/>
+            <a:off x="2758744" y="2944368"/>
+            <a:ext cx="7772400" cy="502920"/>
           </a:xfrm>
           <a:prstGeom prst="rect">
             <a:avLst/>
@@ -7409,13 +6877,13 @@
               </a:spcAft>
             </a:pPr>
             <a:r>
-              <a:rPr sz="2200" b="0">
+              <a:rPr sz="2400" b="0">
                 <a:solidFill>
                   <a:srgbClr val="502814"/>
                 </a:solidFill>
                 <a:latin typeface="Microsoft YaHei"/>
               </a:rPr>
-              <a:t>策展主题一：自由与规则</a:t>
+              <a:t>策展主题一：自由可贵，但需守规则</a:t>
             </a:r>
           </a:p>
         </p:txBody>
@@ -7630,7 +7098,7 @@
                 </a:solidFill>
                 <a:latin typeface="Microsoft YaHei"/>
               </a:rPr>
-              <a:t>课后延伸</a:t>
+              <a:t>回顾收获</a:t>
             </a:r>
           </a:p>
         </p:txBody>
@@ -7643,7 +7111,7 @@
         </p:nvSpPr>
         <p:spPr>
           <a:xfrm>
-            <a:off x="1371600" y="1051560"/>
+            <a:off x="1371600" y="960120"/>
             <a:ext cx="9418320" cy="822960"/>
           </a:xfrm>
           <a:prstGeom prst="rect">
@@ -7669,7 +7137,7 @@
                 </a:solidFill>
                 <a:latin typeface="Microsoft YaHei"/>
               </a:rPr>
-              <a:t>课后作业</a:t>
+              <a:t>课堂小结</a:t>
             </a:r>
           </a:p>
         </p:txBody>
@@ -7682,7 +7150,7 @@
         </p:nvSpPr>
         <p:spPr>
           <a:xfrm>
-            <a:off x="3200400" y="1691640"/>
+            <a:off x="3200400" y="1600200"/>
             <a:ext cx="5760720" cy="27432"/>
           </a:xfrm>
           <a:prstGeom prst="rect">
@@ -7725,8 +7193,8 @@
         </p:nvSpPr>
         <p:spPr>
           <a:xfrm>
-            <a:off x="1295704" y="1737360"/>
-            <a:ext cx="9601200" cy="1545336"/>
+            <a:off x="1295704" y="1645920"/>
+            <a:ext cx="9601200" cy="2240280"/>
           </a:xfrm>
           <a:prstGeom prst="roundRect">
             <a:avLst/>
@@ -7770,8 +7238,8 @@
         </p:nvSpPr>
         <p:spPr>
           <a:xfrm>
-            <a:off x="2621584" y="1920240"/>
-            <a:ext cx="347472" cy="347472"/>
+            <a:off x="2255824" y="1828800"/>
+            <a:ext cx="384048" cy="384048"/>
           </a:xfrm>
           <a:prstGeom prst="ellipse">
             <a:avLst/>
@@ -7813,8 +7281,8 @@
         </p:nvSpPr>
         <p:spPr>
           <a:xfrm>
-            <a:off x="2621584" y="1938528"/>
-            <a:ext cx="347472" cy="329184"/>
+            <a:off x="2255824" y="1847088"/>
+            <a:ext cx="384048" cy="365760"/>
           </a:xfrm>
           <a:prstGeom prst="rect">
             <a:avLst/>
@@ -7833,7 +7301,7 @@
               </a:spcAft>
             </a:pPr>
             <a:r>
-              <a:rPr sz="1400" b="1">
+              <a:rPr sz="1600" b="1">
                 <a:solidFill>
                   <a:srgbClr val="FFFFFF"/>
                 </a:solidFill>
@@ -7852,8 +7320,713 @@
         </p:nvSpPr>
         <p:spPr>
           <a:xfrm>
-            <a:off x="3078784" y="1901952"/>
-            <a:ext cx="7863840" cy="457200"/>
+            <a:off x="2758744" y="1810512"/>
+            <a:ext cx="7772400" cy="502920"/>
+          </a:xfrm>
+          <a:prstGeom prst="rect">
+            <a:avLst/>
+          </a:prstGeom>
+          <a:noFill/>
+        </p:spPr>
+        <p:txBody>
+          <a:bodyPr wrap="none">
+            <a:spAutoFit/>
+          </a:bodyPr>
+          <a:lstStyle/>
+          <a:p>
+            <a:pPr algn="l">
+              <a:spcAft>
+                <a:spcPts val="1000"/>
+              </a:spcAft>
+            </a:pPr>
+            <a:r>
+              <a:rPr sz="2400" b="0">
+                <a:solidFill>
+                  <a:srgbClr val="502814"/>
+                </a:solidFill>
+                <a:latin typeface="Microsoft YaHei"/>
+              </a:rPr>
+              <a:t>想象精彩，来自变化中的因果回应</a:t>
+            </a:r>
+          </a:p>
+        </p:txBody>
+      </p:sp>
+      <p:sp>
+        <p:nvSpPr>
+          <p:cNvPr id="14" name="Oval 13"/>
+          <p:cNvSpPr/>
+          <p:nvPr/>
+        </p:nvSpPr>
+        <p:spPr>
+          <a:xfrm>
+            <a:off x="2255824" y="2395728"/>
+            <a:ext cx="384048" cy="384048"/>
+          </a:xfrm>
+          <a:prstGeom prst="ellipse">
+            <a:avLst/>
+          </a:prstGeom>
+          <a:solidFill>
+            <a:srgbClr val="DC5028"/>
+          </a:solidFill>
+          <a:ln>
+            <a:noFill/>
+          </a:ln>
+        </p:spPr>
+        <p:style>
+          <a:lnRef idx="1">
+            <a:schemeClr val="accent1"/>
+          </a:lnRef>
+          <a:fillRef idx="3">
+            <a:schemeClr val="accent1"/>
+          </a:fillRef>
+          <a:effectRef idx="2">
+            <a:schemeClr val="accent1"/>
+          </a:effectRef>
+          <a:fontRef idx="minor">
+            <a:schemeClr val="lt1"/>
+          </a:fontRef>
+        </p:style>
+        <p:txBody>
+          <a:bodyPr rtlCol="0" anchor="ctr"/>
+          <a:lstStyle/>
+          <a:p>
+            <a:pPr algn="ctr"/>
+          </a:p>
+        </p:txBody>
+      </p:sp>
+      <p:sp>
+        <p:nvSpPr>
+          <p:cNvPr id="15" name="TextBox 14"/>
+          <p:cNvSpPr txBox="1"/>
+          <p:nvPr/>
+        </p:nvSpPr>
+        <p:spPr>
+          <a:xfrm>
+            <a:off x="2255824" y="2414016"/>
+            <a:ext cx="384048" cy="365760"/>
+          </a:xfrm>
+          <a:prstGeom prst="rect">
+            <a:avLst/>
+          </a:prstGeom>
+          <a:noFill/>
+        </p:spPr>
+        <p:txBody>
+          <a:bodyPr wrap="none">
+            <a:spAutoFit/>
+          </a:bodyPr>
+          <a:lstStyle/>
+          <a:p>
+            <a:pPr algn="ctr">
+              <a:spcAft>
+                <a:spcPts val="1000"/>
+              </a:spcAft>
+            </a:pPr>
+            <a:r>
+              <a:rPr sz="1600" b="1">
+                <a:solidFill>
+                  <a:srgbClr val="FFFFFF"/>
+                </a:solidFill>
+                <a:latin typeface="Microsoft YaHei"/>
+              </a:rPr>
+              <a:t>2</a:t>
+            </a:r>
+          </a:p>
+        </p:txBody>
+      </p:sp>
+      <p:sp>
+        <p:nvSpPr>
+          <p:cNvPr id="16" name="TextBox 15"/>
+          <p:cNvSpPr txBox="1"/>
+          <p:nvPr/>
+        </p:nvSpPr>
+        <p:spPr>
+          <a:xfrm>
+            <a:off x="2758744" y="2377440"/>
+            <a:ext cx="7772400" cy="502920"/>
+          </a:xfrm>
+          <a:prstGeom prst="rect">
+            <a:avLst/>
+          </a:prstGeom>
+          <a:noFill/>
+        </p:spPr>
+        <p:txBody>
+          <a:bodyPr wrap="none">
+            <a:spAutoFit/>
+          </a:bodyPr>
+          <a:lstStyle/>
+          <a:p>
+            <a:pPr algn="l">
+              <a:spcAft>
+                <a:spcPts val="1000"/>
+              </a:spcAft>
+            </a:pPr>
+            <a:r>
+              <a:rPr sz="2400" b="0">
+                <a:solidFill>
+                  <a:srgbClr val="502814"/>
+                </a:solidFill>
+                <a:latin typeface="Microsoft YaHei"/>
+              </a:rPr>
+              <a:t>神魔有法力，也有机敏、急切、好胜等人情味</a:t>
+            </a:r>
+          </a:p>
+        </p:txBody>
+      </p:sp>
+      <p:sp>
+        <p:nvSpPr>
+          <p:cNvPr id="17" name="Oval 16"/>
+          <p:cNvSpPr/>
+          <p:nvPr/>
+        </p:nvSpPr>
+        <p:spPr>
+          <a:xfrm>
+            <a:off x="2255824" y="2962656"/>
+            <a:ext cx="384048" cy="384048"/>
+          </a:xfrm>
+          <a:prstGeom prst="ellipse">
+            <a:avLst/>
+          </a:prstGeom>
+          <a:solidFill>
+            <a:srgbClr val="DC5028"/>
+          </a:solidFill>
+          <a:ln>
+            <a:noFill/>
+          </a:ln>
+        </p:spPr>
+        <p:style>
+          <a:lnRef idx="1">
+            <a:schemeClr val="accent1"/>
+          </a:lnRef>
+          <a:fillRef idx="3">
+            <a:schemeClr val="accent1"/>
+          </a:fillRef>
+          <a:effectRef idx="2">
+            <a:schemeClr val="accent1"/>
+          </a:effectRef>
+          <a:fontRef idx="minor">
+            <a:schemeClr val="lt1"/>
+          </a:fontRef>
+        </p:style>
+        <p:txBody>
+          <a:bodyPr rtlCol="0" anchor="ctr"/>
+          <a:lstStyle/>
+          <a:p>
+            <a:pPr algn="ctr"/>
+          </a:p>
+        </p:txBody>
+      </p:sp>
+      <p:sp>
+        <p:nvSpPr>
+          <p:cNvPr id="18" name="TextBox 17"/>
+          <p:cNvSpPr txBox="1"/>
+          <p:nvPr/>
+        </p:nvSpPr>
+        <p:spPr>
+          <a:xfrm>
+            <a:off x="2255824" y="2980944"/>
+            <a:ext cx="384048" cy="365760"/>
+          </a:xfrm>
+          <a:prstGeom prst="rect">
+            <a:avLst/>
+          </a:prstGeom>
+          <a:noFill/>
+        </p:spPr>
+        <p:txBody>
+          <a:bodyPr wrap="none">
+            <a:spAutoFit/>
+          </a:bodyPr>
+          <a:lstStyle/>
+          <a:p>
+            <a:pPr algn="ctr">
+              <a:spcAft>
+                <a:spcPts val="1000"/>
+              </a:spcAft>
+            </a:pPr>
+            <a:r>
+              <a:rPr sz="1600" b="1">
+                <a:solidFill>
+                  <a:srgbClr val="FFFFFF"/>
+                </a:solidFill>
+                <a:latin typeface="Microsoft YaHei"/>
+              </a:rPr>
+              <a:t>3</a:t>
+            </a:r>
+          </a:p>
+        </p:txBody>
+      </p:sp>
+      <p:sp>
+        <p:nvSpPr>
+          <p:cNvPr id="19" name="TextBox 18"/>
+          <p:cNvSpPr txBox="1"/>
+          <p:nvPr/>
+        </p:nvSpPr>
+        <p:spPr>
+          <a:xfrm>
+            <a:off x="2758744" y="2944368"/>
+            <a:ext cx="7772400" cy="502920"/>
+          </a:xfrm>
+          <a:prstGeom prst="rect">
+            <a:avLst/>
+          </a:prstGeom>
+          <a:noFill/>
+        </p:spPr>
+        <p:txBody>
+          <a:bodyPr wrap="none">
+            <a:spAutoFit/>
+          </a:bodyPr>
+          <a:lstStyle/>
+          <a:p>
+            <a:pPr algn="l">
+              <a:spcAft>
+                <a:spcPts val="1000"/>
+              </a:spcAft>
+            </a:pPr>
+            <a:r>
+              <a:rPr sz="2400" b="0">
+                <a:solidFill>
+                  <a:srgbClr val="502814"/>
+                </a:solidFill>
+                <a:latin typeface="Microsoft YaHei"/>
+              </a:rPr>
+              <a:t>策展主题：自由与规则</a:t>
+            </a:r>
+          </a:p>
+        </p:txBody>
+      </p:sp>
+    </p:spTree>
+  </p:cSld>
+  <p:clrMapOvr>
+    <a:masterClrMapping/>
+  </p:clrMapOvr>
+</p:sld>
+</file>
+
+<file path=ppt/slides/slide9.xml><?xml version="1.0" encoding="utf-8"?>
+<p:sld xmlns:a="http://schemas.openxmlformats.org/drawingml/2006/main" xmlns:p="http://schemas.openxmlformats.org/presentationml/2006/main" xmlns:r="http://schemas.openxmlformats.org/officeDocument/2006/relationships">
+  <p:cSld>
+    <p:spTree>
+      <p:nvGrpSpPr>
+        <p:cNvPr id="1" name=""/>
+        <p:cNvGrpSpPr/>
+        <p:nvPr/>
+      </p:nvGrpSpPr>
+      <p:grpSpPr/>
+      <p:pic>
+        <p:nvPicPr>
+          <p:cNvPr id="2" name="Picture 1" descr="bg_wukong.png"/>
+          <p:cNvPicPr>
+            <a:picLocks noChangeAspect="1"/>
+          </p:cNvPicPr>
+          <p:nvPr/>
+        </p:nvPicPr>
+        <p:blipFill>
+          <a:blip r:embed="rId2"/>
+          <a:stretch>
+            <a:fillRect/>
+          </a:stretch>
+        </p:blipFill>
+        <p:spPr>
+          <a:xfrm>
+            <a:off x="0" y="0"/>
+            <a:ext cx="12191695" cy="6858000"/>
+          </a:xfrm>
+          <a:prstGeom prst="rect">
+            <a:avLst/>
+          </a:prstGeom>
+        </p:spPr>
+      </p:pic>
+      <p:sp>
+        <p:nvSpPr>
+          <p:cNvPr id="3" name="Rectangle 2"/>
+          <p:cNvSpPr/>
+          <p:nvPr/>
+        </p:nvSpPr>
+        <p:spPr>
+          <a:xfrm>
+            <a:off x="292608" y="274320"/>
+            <a:ext cx="11594592" cy="6300216"/>
+          </a:xfrm>
+          <a:prstGeom prst="rect">
+            <a:avLst/>
+          </a:prstGeom>
+          <a:noFill/>
+          <a:ln w="31750">
+            <a:solidFill>
+              <a:srgbClr val="C85A32"/>
+            </a:solidFill>
+          </a:ln>
+        </p:spPr>
+        <p:style>
+          <a:lnRef idx="1">
+            <a:schemeClr val="accent1"/>
+          </a:lnRef>
+          <a:fillRef idx="3">
+            <a:schemeClr val="accent1"/>
+          </a:fillRef>
+          <a:effectRef idx="2">
+            <a:schemeClr val="accent1"/>
+          </a:effectRef>
+          <a:fontRef idx="minor">
+            <a:schemeClr val="lt1"/>
+          </a:fontRef>
+        </p:style>
+        <p:txBody>
+          <a:bodyPr rtlCol="0" anchor="ctr"/>
+          <a:lstStyle/>
+          <a:p>
+            <a:pPr algn="ctr"/>
+          </a:p>
+        </p:txBody>
+      </p:sp>
+      <p:pic>
+        <p:nvPicPr>
+          <p:cNvPr id="4" name="Picture 3" descr="corner_wukong_tl.png"/>
+          <p:cNvPicPr>
+            <a:picLocks noChangeAspect="1"/>
+          </p:cNvPicPr>
+          <p:nvPr/>
+        </p:nvPicPr>
+        <p:blipFill>
+          <a:blip r:embed="rId3"/>
+          <a:stretch>
+            <a:fillRect/>
+          </a:stretch>
+        </p:blipFill>
+        <p:spPr>
+          <a:xfrm>
+            <a:off x="-45720" y="-45720"/>
+            <a:ext cx="2011680" cy="2011680"/>
+          </a:xfrm>
+          <a:prstGeom prst="rect">
+            <a:avLst/>
+          </a:prstGeom>
+        </p:spPr>
+      </p:pic>
+      <p:pic>
+        <p:nvPicPr>
+          <p:cNvPr id="5" name="Picture 4" descr="corner_wukong_tr.png"/>
+          <p:cNvPicPr>
+            <a:picLocks noChangeAspect="1"/>
+          </p:cNvPicPr>
+          <p:nvPr/>
+        </p:nvPicPr>
+        <p:blipFill>
+          <a:blip r:embed="rId4"/>
+          <a:stretch>
+            <a:fillRect/>
+          </a:stretch>
+        </p:blipFill>
+        <p:spPr>
+          <a:xfrm>
+            <a:off x="9875520" y="-45720"/>
+            <a:ext cx="2011680" cy="2011680"/>
+          </a:xfrm>
+          <a:prstGeom prst="rect">
+            <a:avLst/>
+          </a:prstGeom>
+        </p:spPr>
+      </p:pic>
+      <p:sp>
+        <p:nvSpPr>
+          <p:cNvPr id="6" name="Rounded Rectangle 5"/>
+          <p:cNvSpPr/>
+          <p:nvPr/>
+        </p:nvSpPr>
+        <p:spPr>
+          <a:xfrm>
+            <a:off x="4953304" y="502920"/>
+            <a:ext cx="2286000" cy="411480"/>
+          </a:xfrm>
+          <a:prstGeom prst="roundRect">
+            <a:avLst/>
+          </a:prstGeom>
+          <a:solidFill>
+            <a:srgbClr val="FFB464"/>
+          </a:solidFill>
+          <a:ln>
+            <a:noFill/>
+          </a:ln>
+        </p:spPr>
+        <p:style>
+          <a:lnRef idx="1">
+            <a:schemeClr val="accent1"/>
+          </a:lnRef>
+          <a:fillRef idx="3">
+            <a:schemeClr val="accent1"/>
+          </a:fillRef>
+          <a:effectRef idx="2">
+            <a:schemeClr val="accent1"/>
+          </a:effectRef>
+          <a:fontRef idx="minor">
+            <a:schemeClr val="lt1"/>
+          </a:fontRef>
+        </p:style>
+        <p:txBody>
+          <a:bodyPr rtlCol="0" anchor="ctr"/>
+          <a:lstStyle/>
+          <a:p>
+            <a:pPr algn="ctr"/>
+          </a:p>
+        </p:txBody>
+      </p:sp>
+      <p:sp>
+        <p:nvSpPr>
+          <p:cNvPr id="7" name="TextBox 6"/>
+          <p:cNvSpPr txBox="1"/>
+          <p:nvPr/>
+        </p:nvSpPr>
+        <p:spPr>
+          <a:xfrm>
+            <a:off x="4953304" y="521208"/>
+            <a:ext cx="2286000" cy="384048"/>
+          </a:xfrm>
+          <a:prstGeom prst="rect">
+            <a:avLst/>
+          </a:prstGeom>
+          <a:noFill/>
+        </p:spPr>
+        <p:txBody>
+          <a:bodyPr wrap="none">
+            <a:spAutoFit/>
+          </a:bodyPr>
+          <a:lstStyle/>
+          <a:p>
+            <a:pPr algn="ctr">
+              <a:spcAft>
+                <a:spcPts val="1000"/>
+              </a:spcAft>
+            </a:pPr>
+            <a:r>
+              <a:rPr sz="1800" b="1">
+                <a:solidFill>
+                  <a:srgbClr val="502814"/>
+                </a:solidFill>
+                <a:latin typeface="Microsoft YaHei"/>
+              </a:rPr>
+              <a:t>课后延伸</a:t>
+            </a:r>
+          </a:p>
+        </p:txBody>
+      </p:sp>
+      <p:sp>
+        <p:nvSpPr>
+          <p:cNvPr id="8" name="TextBox 7"/>
+          <p:cNvSpPr txBox="1"/>
+          <p:nvPr/>
+        </p:nvSpPr>
+        <p:spPr>
+          <a:xfrm>
+            <a:off x="1371600" y="960120"/>
+            <a:ext cx="9418320" cy="822960"/>
+          </a:xfrm>
+          <a:prstGeom prst="rect">
+            <a:avLst/>
+          </a:prstGeom>
+          <a:noFill/>
+        </p:spPr>
+        <p:txBody>
+          <a:bodyPr wrap="square">
+            <a:spAutoFit/>
+          </a:bodyPr>
+          <a:lstStyle/>
+          <a:p>
+            <a:pPr algn="ctr">
+              <a:spcAft>
+                <a:spcPts val="1000"/>
+              </a:spcAft>
+            </a:pPr>
+            <a:r>
+              <a:rPr sz="3600" b="1">
+                <a:solidFill>
+                  <a:srgbClr val="DC5028"/>
+                </a:solidFill>
+                <a:latin typeface="Microsoft YaHei"/>
+              </a:rPr>
+              <a:t>课后作业</a:t>
+            </a:r>
+          </a:p>
+        </p:txBody>
+      </p:sp>
+      <p:sp>
+        <p:nvSpPr>
+          <p:cNvPr id="9" name="Rectangle 8"/>
+          <p:cNvSpPr/>
+          <p:nvPr/>
+        </p:nvSpPr>
+        <p:spPr>
+          <a:xfrm>
+            <a:off x="3200400" y="1600200"/>
+            <a:ext cx="5760720" cy="27432"/>
+          </a:xfrm>
+          <a:prstGeom prst="rect">
+            <a:avLst/>
+          </a:prstGeom>
+          <a:solidFill>
+            <a:srgbClr val="FFB464"/>
+          </a:solidFill>
+          <a:ln>
+            <a:noFill/>
+          </a:ln>
+        </p:spPr>
+        <p:style>
+          <a:lnRef idx="1">
+            <a:schemeClr val="accent1"/>
+          </a:lnRef>
+          <a:fillRef idx="3">
+            <a:schemeClr val="accent1"/>
+          </a:fillRef>
+          <a:effectRef idx="2">
+            <a:schemeClr val="accent1"/>
+          </a:effectRef>
+          <a:fontRef idx="minor">
+            <a:schemeClr val="lt1"/>
+          </a:fontRef>
+        </p:style>
+        <p:txBody>
+          <a:bodyPr rtlCol="0" anchor="ctr"/>
+          <a:lstStyle/>
+          <a:p>
+            <a:pPr algn="ctr"/>
+          </a:p>
+        </p:txBody>
+      </p:sp>
+      <p:sp>
+        <p:nvSpPr>
+          <p:cNvPr id="10" name="Rounded Rectangle 9"/>
+          <p:cNvSpPr/>
+          <p:nvPr/>
+        </p:nvSpPr>
+        <p:spPr>
+          <a:xfrm>
+            <a:off x="1295704" y="1645920"/>
+            <a:ext cx="9601200" cy="1645920"/>
+          </a:xfrm>
+          <a:prstGeom prst="roundRect">
+            <a:avLst/>
+          </a:prstGeom>
+          <a:solidFill>
+            <a:srgbClr val="FFF8F0"/>
+          </a:solidFill>
+          <a:ln w="19050">
+            <a:solidFill>
+              <a:srgbClr val="FFB464"/>
+            </a:solidFill>
+          </a:ln>
+        </p:spPr>
+        <p:style>
+          <a:lnRef idx="1">
+            <a:schemeClr val="accent1"/>
+          </a:lnRef>
+          <a:fillRef idx="3">
+            <a:schemeClr val="accent1"/>
+          </a:fillRef>
+          <a:effectRef idx="2">
+            <a:schemeClr val="accent1"/>
+          </a:effectRef>
+          <a:fontRef idx="minor">
+            <a:schemeClr val="lt1"/>
+          </a:fontRef>
+        </p:style>
+        <p:txBody>
+          <a:bodyPr rtlCol="0" anchor="ctr"/>
+          <a:lstStyle/>
+          <a:p>
+            <a:pPr algn="ctr"/>
+          </a:p>
+        </p:txBody>
+      </p:sp>
+      <p:sp>
+        <p:nvSpPr>
+          <p:cNvPr id="11" name="Oval 10"/>
+          <p:cNvSpPr/>
+          <p:nvPr/>
+        </p:nvSpPr>
+        <p:spPr>
+          <a:xfrm>
+            <a:off x="2255824" y="1828800"/>
+            <a:ext cx="384048" cy="384048"/>
+          </a:xfrm>
+          <a:prstGeom prst="ellipse">
+            <a:avLst/>
+          </a:prstGeom>
+          <a:solidFill>
+            <a:srgbClr val="DC5028"/>
+          </a:solidFill>
+          <a:ln>
+            <a:noFill/>
+          </a:ln>
+        </p:spPr>
+        <p:style>
+          <a:lnRef idx="1">
+            <a:schemeClr val="accent1"/>
+          </a:lnRef>
+          <a:fillRef idx="3">
+            <a:schemeClr val="accent1"/>
+          </a:fillRef>
+          <a:effectRef idx="2">
+            <a:schemeClr val="accent1"/>
+          </a:effectRef>
+          <a:fontRef idx="minor">
+            <a:schemeClr val="lt1"/>
+          </a:fontRef>
+        </p:style>
+        <p:txBody>
+          <a:bodyPr rtlCol="0" anchor="ctr"/>
+          <a:lstStyle/>
+          <a:p>
+            <a:pPr algn="ctr"/>
+          </a:p>
+        </p:txBody>
+      </p:sp>
+      <p:sp>
+        <p:nvSpPr>
+          <p:cNvPr id="12" name="TextBox 11"/>
+          <p:cNvSpPr txBox="1"/>
+          <p:nvPr/>
+        </p:nvSpPr>
+        <p:spPr>
+          <a:xfrm>
+            <a:off x="2255824" y="1847088"/>
+            <a:ext cx="384048" cy="365760"/>
+          </a:xfrm>
+          <a:prstGeom prst="rect">
+            <a:avLst/>
+          </a:prstGeom>
+          <a:noFill/>
+        </p:spPr>
+        <p:txBody>
+          <a:bodyPr wrap="none">
+            <a:spAutoFit/>
+          </a:bodyPr>
+          <a:lstStyle/>
+          <a:p>
+            <a:pPr algn="ctr">
+              <a:spcAft>
+                <a:spcPts val="1000"/>
+              </a:spcAft>
+            </a:pPr>
+            <a:r>
+              <a:rPr sz="1600" b="1">
+                <a:solidFill>
+                  <a:srgbClr val="FFFFFF"/>
+                </a:solidFill>
+                <a:latin typeface="Microsoft YaHei"/>
+              </a:rPr>
+              <a:t>1</a:t>
+            </a:r>
+          </a:p>
+        </p:txBody>
+      </p:sp>
+      <p:sp>
+        <p:nvSpPr>
+          <p:cNvPr id="13" name="TextBox 12"/>
+          <p:cNvSpPr txBox="1"/>
+          <p:nvPr/>
+        </p:nvSpPr>
+        <p:spPr>
+          <a:xfrm>
+            <a:off x="2758744" y="1810512"/>
+            <a:ext cx="7772400" cy="502920"/>
           </a:xfrm>
           <a:prstGeom prst="rect">
             <a:avLst/>
@@ -7891,8 +8064,8 @@
         </p:nvSpPr>
         <p:spPr>
           <a:xfrm>
-            <a:off x="2621584" y="2487168"/>
-            <a:ext cx="347472" cy="347472"/>
+            <a:off x="2255824" y="2395728"/>
+            <a:ext cx="384048" cy="384048"/>
           </a:xfrm>
           <a:prstGeom prst="ellipse">
             <a:avLst/>
@@ -7934,8 +8107,8 @@
         </p:nvSpPr>
         <p:spPr>
           <a:xfrm>
-            <a:off x="2621584" y="2505456"/>
-            <a:ext cx="347472" cy="329184"/>
+            <a:off x="2255824" y="2414016"/>
+            <a:ext cx="384048" cy="365760"/>
           </a:xfrm>
           <a:prstGeom prst="rect">
             <a:avLst/>
@@ -7954,7 +8127,7 @@
               </a:spcAft>
             </a:pPr>
             <a:r>
-              <a:rPr sz="1400" b="1">
+              <a:rPr sz="1600" b="1">
                 <a:solidFill>
                   <a:srgbClr val="FFFFFF"/>
                 </a:solidFill>
@@ -7973,8 +8146,8 @@
         </p:nvSpPr>
         <p:spPr>
           <a:xfrm>
-            <a:off x="3078784" y="2468880"/>
-            <a:ext cx="7863840" cy="457200"/>
+            <a:off x="2758744" y="2377440"/>
+            <a:ext cx="7772400" cy="502920"/>
           </a:xfrm>
           <a:prstGeom prst="rect">
             <a:avLst/>
@@ -7999,7 +8172,7 @@
                 </a:solidFill>
                 <a:latin typeface="Microsoft YaHei"/>
               </a:rPr>
-              <a:t>积累：《西游记》作者吴承恩，成书明代；再写一个孙悟空经典情节</a:t>
+              <a:t>链接：作者吴承恩，成书明代，再写一个经典情节</a:t>
             </a:r>
           </a:p>
         </p:txBody>

</xml_diff>